<commit_message>
Implement obstacle avoidance and spatial grid mechanics in CrowdSim
- Added obstacle handling with circular and AABB (axis-aligned bounding box) types.
- Implemented obstacle initialization based on different scenarios (pillars and bottlenecks).
- Developed functions for computing repulsive forces from obstacles and resolving agent penetration.
- Introduced a spatial grid for efficient neighbor querying, reducing computational complexity.
- Created tests for agent initialization, goal steering, obstacle mechanics, spatial grid vs brute force, and sequential vs parallel simulation equivalence.
- Ensured that the simulation maintains physical invariants and validates results across different configurations.
</commit_message>
<xml_diff>
--- a/CrowdSim/presentation/CrowdSim_Project_Presentation.pptx
+++ b/CrowdSim/presentation/CrowdSim_Project_Presentation.pptx
@@ -516,7 +516,7 @@
           <a:lstStyle/>
           <a:p>
             <a:r>
-              <a:t>Respected guide and examiners, good morning. Today I am presenting our Parallel Computing mini-project titled 'CrowdSim: Sequential and OpenMP-Based Parallel Particle Movement Simulator'. This project demonstrates how shared-memory multi-core processors can accelerate computational physics workloads using OpenMP directives, while verifying that parallel execution preserves exact mathematical correctness.</a:t>
+              <a:t>Good morning, respected guide and examiners. Today I am presenting our parallel computing project, 'CrowdFlow: A Parallel Crowd Dynamics Simulator and OpenMP Performance Analysis Platform'. This project transitions beyond basic independent particles into true crowd dynamics, implementing continuous steering forces, an O(N) spatial partitioning grid, and multi-core OpenMP acceleration.</a:t>
             </a:r>
           </a:p>
         </p:txBody>
@@ -586,7 +586,7 @@
           <a:lstStyle/>
           <a:p>
             <a:r>
-              <a:t>We evaluate performance using standard VTU Module 2 formulas: Speedup, which is sequential time divided by parallel time, and Parallel Efficiency, which divides speedup by thread count. Amdahl's Law explains why efficiency is less than 100%: serial portions such as time-step synchronization and thread coordination set a theoretical ceiling on speedup.</a:t>
+              <a:t>We evaluate performance using standard VTU formulas: Speedup, Parallel Efficiency, and Algorithmic Speedup. Amdahl's Law explains why efficiency decreases at higher core counts: serial barriers and memory bus saturation limit maximum achievable speedup.</a:t>
             </a:r>
           </a:p>
         </p:txBody>
@@ -656,7 +656,7 @@
           <a:lstStyle/>
           <a:p>
             <a:r>
-              <a:t>These are real, verified measurements from our test machine. For 50,000 particles and 8 threads, sequential execution took 41.89 ms while parallel execution finished in just 9.10 ms—yielding a 4.60× speedup and 57.5% parallel efficiency. Notice that larger workloads yield better efficiency because computational work dominates thread overhead.</a:t>
+              <a:t>These are real empirical measurements on our 12-core test machine. On 5,000 agents, 8 threads reduce execution time from 182.36 ms to 53.48 ms, achieving a 3.41× speedup while maintaining exact mathematical equivalence.</a:t>
             </a:r>
           </a:p>
         </p:txBody>
@@ -726,7 +726,7 @@
           <a:lstStyle/>
           <a:p>
             <a:r>
-              <a:t>Here is a screenshot of our working web dashboard. The left panel allows entering parameters. The center Canvas displays an 80 by 30 spatial density heatmap returned directly by our C program. The right panel displays the measured times, speedup, efficiency, and confirmation badges proving that all correctness checks passed.</a:t>
+              <a:t>Here is our web dashboard. It visualizes real native simulation data returned by the C engine. Examiners can toggle between viewing individual agents or spatial congestion heatmaps, run live thread scaling sweeps, and export benchmark data to CSV.</a:t>
             </a:r>
           </a:p>
         </p:txBody>
@@ -796,7 +796,7 @@
           <a:lstStyle/>
           <a:p>
             <a:r>
-              <a:t>Our automated test suite runs 15 distinct tests covering thread equivalence with 1, 4, and 8 threads, boundary audits, and invalid input rejection. Every single test passes, proving that parallelization did not compromise numerical stability or physical correctness.</a:t>
+              <a:t>Correctness is verified by 27 automated tests. We proved that spatial grid forces match brute force within 10^-6, and that sequential and OpenMP results match across 1, 2, 4, and 8 threads. AddressSanitizer confirmed zero memory leaks or buffer overflows.</a:t>
             </a:r>
           </a:p>
         </p:txBody>
@@ -866,7 +866,7 @@
           <a:lstStyle/>
           <a:p>
             <a:r>
-              <a:t>This computational pattern applies widely to molecular dynamics and graphics. As an educational mini-project, CrowdSim does not implement inter-particle collisions or human panic psychology. In future work, we could add spatial cell lists for physical collisions and hybrid MPI for multi-node supercomputing clusters.</a:t>
+              <a:t>CrowdFlow's computational patterns apply directly to architectural egress planning and game physics. In future work, we plan to implement SIMD vectorization and hybrid MPI for multi-node supercomputing clusters.</a:t>
             </a:r>
           </a:p>
         </p:txBody>
@@ -936,7 +936,7 @@
           <a:lstStyle/>
           <a:p>
             <a:r>
-              <a:t>In conclusion, CrowdSim demonstrates how shared-memory parallel programming with OpenMP can significantly accelerate independent spatial computations without introducing race conditions. It confirms theoretical scalability concepts from our VTU syllabus with real empirical data. Thank you, and I am now ready for your questions.</a:t>
+              <a:t>In conclusion, CrowdFlow demonstrates how high-performance algorithms and shared-memory parallel programming unite to solve complex computational physics challenges. Thank you, and I look forward to your questions.</a:t>
             </a:r>
           </a:p>
         </p:txBody>
@@ -1006,7 +1006,7 @@
           <a:lstStyle/>
           <a:p>
             <a:r>
-              <a:t>In scientific computing, simulating particles requires updating positions repeatedly over time. On a single CPU core, updating 100,000 particles over 500 steps requires 50 million mathematical calculations, creating a computational bottleneck. Our objective is to investigate whether we can distribute these independent calculations across multiple CPU cores using OpenMP, and to quantify the actual speedup achieved.</a:t>
+              <a:t>In crowd simulations, pedestrians interact with their neighbors. Naively checking all agent pairs requires O(N^2) checks—over 1.25 billion checks per step for 50,000 agents. Our objective is twofold: first, design an O(N) spatial grid to eliminate unnecessary calculations; second, parallelize the workload across CPU cores using OpenMP.</a:t>
             </a:r>
           </a:p>
         </p:txBody>
@@ -1076,7 +1076,7 @@
           <a:lstStyle/>
           <a:p>
             <a:r>
-              <a:t>The project has five key objectives: first, simulate 2D particle physics with boundary reflections; second, implement both sequential and parallel versions; third, measure wall-clock runtimes and calculate speedup and efficiency; fourth, mathematically verify that parallel execution produces identical results; and fifth, wrap the engine in a web dashboard for interactive evaluation.</a:t>
+              <a:t>We set out five clear objectives: first, implement continuous crowd dynamics; second, build an efficient spatial partitioning grid; third, implement a race-free OpenMP architecture; fourth, benchmark scheduling policies under load imbalance; and fifth, build an interactive dashboard.</a:t>
             </a:r>
           </a:p>
         </p:txBody>
@@ -1146,7 +1146,7 @@
           <a:lstStyle/>
           <a:p>
             <a:r>
-              <a:t>Parallel computing divides a computational workload across multiple cores simultaneously. In modern multi-core PCs, we utilize the MIMD shared-memory model. Unlike distributed clusters which require sending messages over networks, all worker threads share the same RAM address space, making data sharing extremely fast.</a:t>
+              <a:t>We utilize shared-memory symmetric multiprocessing. To prevent race conditions when multiple threads read neighbor positions while updating them, we use double-buffering. Threads read from a consistent snapshot and write to disjoint indices in a secondary buffer, ensuring thread safety without mutex locks.</a:t>
             </a:r>
           </a:p>
         </p:txBody>
@@ -1216,7 +1216,7 @@
           <a:lstStyle/>
           <a:p>
             <a:r>
-              <a:t>In the existing sequential approach, only one CPU core is active, leaving up to 90% of modern multi-core computing power idle. Our proposed OpenMP approach engages all available hardware threads, dropping runtime from 41.89 ms to 9.10 ms on 50,000 particles—a 4.6× speedup—while verifying that every coordinate matches the baseline.</a:t>
+              <a:t>CrowdFlow is organized into clean modules: agent kinematics, obstacles, spatial indexing, simulation orchestration, and statistical benchmarking. A lightweight Python server bridges the native C binary to our HTML5 Canvas dashboard.</a:t>
             </a:r>
           </a:p>
         </p:txBody>
@@ -1286,7 +1286,7 @@
           <a:lstStyle/>
           <a:p>
             <a:r>
-              <a:t>Here we see the 3-tier architecture. The web browser provides an interactive dashboard. When the user clicks Run, an HTTP POST request is sent to our Python integration server. The server verifies input safety and invokes our compiled C simulation binary. The C binary executes both sequential and parallel runs, validates results, bins coordinates into an 80 by 30 density grid, and returns structured JSON to the browser.</a:t>
+              <a:t>Our physical model computes three accelerations on each agent: goal relaxation steering toward its target, social separation forces pushing nearby agents apart, and radial repulsion from circular or rectangular obstacles.</a:t>
             </a:r>
           </a:p>
         </p:txBody>
@@ -1356,7 +1356,7 @@
           <a:lstStyle/>
           <a:p>
             <a:r>
-              <a:t>Each particle maintains position and velocity coordinates. At each step, displacement is added. For boundary reflection, simple clamping is fragile if velocity is large. We implemented a periodic folding algorithm using modular arithmetic that cleanly rebounds particles back into the 100 by 40 arena, exactly reversing the velocity vector.</a:t>
+              <a:t>To solve the O(N^2) neighbor problem, we implemented a uniform spatial grid. Because cell size equals the interaction radius, we only need to check the agent's cell and its 8 neighbors. This eliminates over 96% of candidate distance checks.</a:t>
             </a:r>
           </a:p>
         </p:txBody>
@@ -1426,7 +1426,7 @@
           <a:lstStyle/>
           <a:p>
             <a:r>
-              <a:t>Here is the sequential reference implementation. An outer loop iterates through simulation steps, while the inner loop updates each particle in sequence. It executes on one core and serves as the baseline for performance and verification.</a:t>
+              <a:t>Here is our OpenMP parallel loop. Notice the use of default(none) for explicit data scoping. The loop index is private, the input array is read-only, and each thread writes strictly to its own assigned index in the output buffer. OpenMP reductions aggregate counters without atomic lock contention.</a:t>
             </a:r>
           </a:p>
         </p:txBody>
@@ -1496,7 +1496,7 @@
           <a:lstStyle/>
           <a:p>
             <a:r>
-              <a:t>Here is our parallel implementation. Notice the directive #pragma omp parallel for schedule(static). OpenMP forks a team of threads that execute the particle loop concurrently. Because each thread writes strictly to its own separate slice of the particle array, there are zero data races, zero false sharing, and no locks are needed.</a:t>
+              <a:t>When crowds converge on a narrow doorway, agents cluster densely. Static scheduling assigns fixed chunks, so the thread processing the doorway takes 114 ms while other threads sit idle. Dynamic scheduling hands out work in chunks of 64 as threads finish, reducing runtime to 79.5 ms—a 44% efficiency improvement.</a:t>
             </a:r>
           </a:p>
         </p:txBody>
@@ -4498,7 +4498,7 @@
     <p:bg>
       <p:bgPr>
         <a:solidFill>
-          <a:srgbClr val="0F172A"/>
+          <a:srgbClr val="0B0F19"/>
         </a:solidFill>
         <a:effectLst/>
       </p:bgPr>
@@ -4551,13 +4551,13 @@
               </a:spcBef>
               <a:defRPr sz="3200" b="1">
                 <a:solidFill>
-                  <a:srgbClr val="F8FAFC"/>
+                  <a:srgbClr val="F1F5F9"/>
                 </a:solidFill>
                 <a:latin typeface="Arial"/>
               </a:defRPr>
             </a:pPr>
             <a:r>
-              <a:t>CrowdSim: Sequential &amp; OpenMP Parallel Particle Simulator</a:t>
+              <a:t>CrowdFlow: Parallel Crowd Dynamics &amp; OpenMP Analysis</a:t>
             </a:r>
           </a:p>
           <a:p>
@@ -4573,7 +4573,7 @@
               </a:defRPr>
             </a:pPr>
             <a:r>
-              <a:t>Shared-Memory Multi-Core Parallelism • High-Resolution Benchmarking • Web Dashboard</a:t>
+              <a:t>O(N) Spatial Partitioning Grid • Continuous Social Forces • Dynamic Scheduling • Web Dashboard</a:t>
             </a:r>
           </a:p>
           <a:p>
@@ -4584,7 +4584,7 @@
               </a:spcBef>
               <a:defRPr sz="1300">
                 <a:solidFill>
-                  <a:srgbClr val="F8FAFC"/>
+                  <a:srgbClr val="F1F5F9"/>
                 </a:solidFill>
                 <a:latin typeface="Arial"/>
               </a:defRPr>
@@ -4613,7 +4613,7 @@
     <p:bg>
       <p:bgPr>
         <a:solidFill>
-          <a:srgbClr val="0F172A"/>
+          <a:srgbClr val="0B0F19"/>
         </a:solidFill>
         <a:effectLst/>
       </p:bgPr>
@@ -4686,13 +4686,13 @@
             <a:pPr>
               <a:defRPr sz="2400" b="1">
                 <a:solidFill>
-                  <a:srgbClr val="F8FAFC"/>
+                  <a:srgbClr val="F1F5F9"/>
                 </a:solidFill>
                 <a:latin typeface="Arial"/>
               </a:defRPr>
             </a:pPr>
             <a:r>
-              <a:t>Performance Formulation &amp; Amdahl's Law</a:t>
+              <a:t>Performance Formulations &amp; Scalability Metrics</a:t>
             </a:r>
           </a:p>
         </p:txBody>
@@ -4726,13 +4726,13 @@
               </a:spcBef>
               <a:defRPr sz="1500">
                 <a:solidFill>
-                  <a:srgbClr val="F8FAFC"/>
+                  <a:srgbClr val="F1F5F9"/>
                 </a:solidFill>
                 <a:latin typeface="Arial"/>
               </a:defRPr>
             </a:pPr>
             <a:r>
-              <a:t>• Speedup (S):</a:t>
+              <a:t>• Parallel Speedup (S):</a:t>
             </a:r>
             <a:br/>
             <a:r>
@@ -4740,7 +4740,7 @@
             </a:r>
             <a:br/>
             <a:r>
-              <a:t>Measures the relative factor by which execution time was reduced.</a:t>
+              <a:t>Measures execution time acceleration over the single-threaded baseline on identical workloads.</a:t>
             </a:r>
           </a:p>
           <a:p>
@@ -4750,7 +4750,7 @@
               </a:spcBef>
               <a:defRPr sz="1500">
                 <a:solidFill>
-                  <a:srgbClr val="F8FAFC"/>
+                  <a:srgbClr val="F1F5F9"/>
                 </a:solidFill>
                 <a:latin typeface="Arial"/>
               </a:defRPr>
@@ -4760,11 +4760,11 @@
             </a:r>
             <a:br/>
             <a:r>
-              <a:t>E = (Speedup / P) * 100% = (T_sequential / (P * T_parallel)) * 100%</a:t>
+              <a:t>E = (S / P) * 100% = (T_sequential / (P * T_parallel)) * 100%</a:t>
             </a:r>
             <a:br/>
             <a:r>
-              <a:t>Measures how effectively allocated hardware threads (P) are utilized. 100% is ideal linear scaling.</a:t>
+              <a:t>Measures effective core utilization. 100% is ideal linear scaling.</a:t>
             </a:r>
           </a:p>
           <a:p>
@@ -4774,21 +4774,21 @@
               </a:spcBef>
               <a:defRPr sz="1500">
                 <a:solidFill>
-                  <a:srgbClr val="F8FAFC"/>
+                  <a:srgbClr val="F1F5F9"/>
                 </a:solidFill>
                 <a:latin typeface="Arial"/>
               </a:defRPr>
             </a:pPr>
             <a:r>
-              <a:t>• Amdahl's Law Limitation:</a:t>
+              <a:t>• Algorithmic Speedup (S_algo):</a:t>
             </a:r>
             <a:br/>
             <a:r>
-              <a:t>S_max = 1 / ((1 - f) + (f / P)), where f is parallel fraction.</a:t>
+              <a:t>S_algo = T_brute_force / T_spatial_grid</a:t>
             </a:r>
             <a:br/>
             <a:r>
-              <a:t>Outer time-step synchronization, thread creation, and memory bus bandwidth bound maximum speedup.</a:t>
+              <a:t>Quantifies the performance advantage of O(N) spatial partitioning over naive O(N²) pairwise checking.</a:t>
             </a:r>
           </a:p>
           <a:p>
@@ -4798,21 +4798,21 @@
               </a:spcBef>
               <a:defRPr sz="1500">
                 <a:solidFill>
-                  <a:srgbClr val="F8FAFC"/>
+                  <a:srgbClr val="F1F5F9"/>
                 </a:solidFill>
                 <a:latin typeface="Arial"/>
               </a:defRPr>
             </a:pPr>
             <a:r>
-              <a:t>• Worked Example (Real Host Run):</a:t>
+              <a:t>• Amdahl's Law Ceiling:</a:t>
             </a:r>
             <a:br/>
             <a:r>
-              <a:t>T_seq = 41.890 ms, T_par = 9.100 ms, Threads P = 8</a:t>
+              <a:t>S_max = 1 / ((1 - f) + (f / P))</a:t>
             </a:r>
             <a:br/>
             <a:r>
-              <a:t>Speedup S = 41.890 / 9.100 = 4.60x  |  Efficiency E = (4.60 / 8) * 100% = 57.5%</a:t>
+              <a:t>Serial barriers (grid reset, pointer swap, thread synchronisation) bound maximum speedup.</a:t>
             </a:r>
           </a:p>
         </p:txBody>
@@ -4831,7 +4831,7 @@
     <p:bg>
       <p:bgPr>
         <a:solidFill>
-          <a:srgbClr val="0F172A"/>
+          <a:srgbClr val="0B0F19"/>
         </a:solidFill>
         <a:effectLst/>
       </p:bgPr>
@@ -4904,13 +4904,13 @@
             <a:pPr>
               <a:defRPr sz="2400" b="1">
                 <a:solidFill>
-                  <a:srgbClr val="F8FAFC"/>
+                  <a:srgbClr val="F1F5F9"/>
                 </a:solidFill>
                 <a:latin typeface="Arial"/>
               </a:defRPr>
             </a:pPr>
             <a:r>
-              <a:t>Empirical Benchmark Results (12-Core Workstation)</a:t>
+              <a:t>Strong Scaling Benchmark (5,000 Agents, 12-Core System)</a:t>
             </a:r>
           </a:p>
         </p:txBody>
@@ -4934,13 +4934,13 @@
                 <a:tableStyleId>{5C22544A-7EE6-4342-B048-85BDC9FD1C3A}</a:tableStyleId>
               </a:tblPr>
               <a:tblGrid>
-                <a:gridCol w="1554480"/>
+                <a:gridCol w="2011680"/>
                 <a:gridCol w="1188720"/>
-                <a:gridCol w="1280160"/>
                 <a:gridCol w="1645920"/>
                 <a:gridCol w="1645920"/>
-                <a:gridCol w="1645920"/>
-                <a:gridCol w="1737360"/>
+                <a:gridCol w="1371600"/>
+                <a:gridCol w="1371600"/>
+                <a:gridCol w="1463040"/>
               </a:tblGrid>
               <a:tr h="822960">
                 <a:tc>
@@ -4957,37 +4957,13 @@
                         </a:defRPr>
                       </a:pPr>
                       <a:r>
-                        <a:t>Particles</a:t>
+                        <a:t>Mode</a:t>
                       </a:r>
                     </a:p>
                   </a:txBody>
                   <a:tcPr>
                     <a:solidFill>
-                      <a:srgbClr val="1E293B"/>
-                    </a:solidFill>
-                  </a:tcPr>
-                </a:tc>
-                <a:tc>
-                  <a:txBody>
-                    <a:bodyPr/>
-                    <a:lstStyle/>
-                    <a:p>
-                      <a:pPr>
-                        <a:defRPr sz="1200" b="1">
-                          <a:solidFill>
-                            <a:srgbClr val="38BDF8"/>
-                          </a:solidFill>
-                          <a:latin typeface="Arial"/>
-                        </a:defRPr>
-                      </a:pPr>
-                      <a:r>
-                        <a:t>Steps</a:t>
-                      </a:r>
-                    </a:p>
-                  </a:txBody>
-                  <a:tcPr>
-                    <a:solidFill>
-                      <a:srgbClr val="1E293B"/>
+                      <a:srgbClr val="131A29"/>
                     </a:solidFill>
                   </a:tcPr>
                 </a:tc>
@@ -5011,7 +4987,7 @@
                   </a:txBody>
                   <a:tcPr>
                     <a:solidFill>
-                      <a:srgbClr val="1E293B"/>
+                      <a:srgbClr val="131A29"/>
                     </a:solidFill>
                   </a:tcPr>
                 </a:tc>
@@ -5029,13 +5005,13 @@
                         </a:defRPr>
                       </a:pPr>
                       <a:r>
-                        <a:t>Seq Time</a:t>
+                        <a:t>Mean Time</a:t>
                       </a:r>
                     </a:p>
                   </a:txBody>
                   <a:tcPr>
                     <a:solidFill>
-                      <a:srgbClr val="1E293B"/>
+                      <a:srgbClr val="131A29"/>
                     </a:solidFill>
                   </a:tcPr>
                 </a:tc>
@@ -5053,13 +5029,13 @@
                         </a:defRPr>
                       </a:pPr>
                       <a:r>
-                        <a:t>Par Time</a:t>
+                        <a:t>Median Time</a:t>
                       </a:r>
                     </a:p>
                   </a:txBody>
                   <a:tcPr>
                     <a:solidFill>
-                      <a:srgbClr val="1E293B"/>
+                      <a:srgbClr val="131A29"/>
                     </a:solidFill>
                   </a:tcPr>
                 </a:tc>
@@ -5083,7 +5059,7 @@
                   </a:txBody>
                   <a:tcPr>
                     <a:solidFill>
-                      <a:srgbClr val="1E293B"/>
+                      <a:srgbClr val="131A29"/>
                     </a:solidFill>
                   </a:tcPr>
                 </a:tc>
@@ -5107,7 +5083,31 @@
                   </a:txBody>
                   <a:tcPr>
                     <a:solidFill>
-                      <a:srgbClr val="1E293B"/>
+                      <a:srgbClr val="131A29"/>
+                    </a:solidFill>
+                  </a:tcPr>
+                </a:tc>
+                <a:tc>
+                  <a:txBody>
+                    <a:bodyPr/>
+                    <a:lstStyle/>
+                    <a:p>
+                      <a:pPr>
+                        <a:defRPr sz="1200" b="1">
+                          <a:solidFill>
+                            <a:srgbClr val="38BDF8"/>
+                          </a:solidFill>
+                          <a:latin typeface="Arial"/>
+                        </a:defRPr>
+                      </a:pPr>
+                      <a:r>
+                        <a:t>Equivalence</a:t>
+                      </a:r>
+                    </a:p>
+                  </a:txBody>
+                  <a:tcPr>
+                    <a:solidFill>
+                      <a:srgbClr val="131A29"/>
                     </a:solidFill>
                   </a:tcPr>
                 </a:tc>
@@ -5121,13 +5121,13 @@
                       <a:pPr>
                         <a:defRPr sz="1200">
                           <a:solidFill>
-                            <a:srgbClr val="F8FAFC"/>
+                            <a:srgbClr val="F1F5F9"/>
                           </a:solidFill>
                           <a:latin typeface="Arial"/>
                         </a:defRPr>
                       </a:pPr>
                       <a:r>
-                        <a:t>10,000</a:t>
+                        <a:t>Sequential</a:t>
                       </a:r>
                     </a:p>
                   </a:txBody>
@@ -5141,13 +5141,13 @@
                       <a:pPr>
                         <a:defRPr sz="1200">
                           <a:solidFill>
-                            <a:srgbClr val="F8FAFC"/>
+                            <a:srgbClr val="F1F5F9"/>
                           </a:solidFill>
                           <a:latin typeface="Arial"/>
                         </a:defRPr>
                       </a:pPr>
                       <a:r>
-                        <a:t>200</a:t>
+                        <a:t>1</a:t>
                       </a:r>
                     </a:p>
                   </a:txBody>
@@ -5161,7 +5161,271 @@
                       <a:pPr>
                         <a:defRPr sz="1200">
                           <a:solidFill>
-                            <a:srgbClr val="F8FAFC"/>
+                            <a:srgbClr val="F1F5F9"/>
+                          </a:solidFill>
+                          <a:latin typeface="Arial"/>
+                        </a:defRPr>
+                      </a:pPr>
+                      <a:r>
+                        <a:t>182.36 ms</a:t>
+                      </a:r>
+                    </a:p>
+                  </a:txBody>
+                  <a:tcPr/>
+                </a:tc>
+                <a:tc>
+                  <a:txBody>
+                    <a:bodyPr/>
+                    <a:lstStyle/>
+                    <a:p>
+                      <a:pPr>
+                        <a:defRPr sz="1200">
+                          <a:solidFill>
+                            <a:srgbClr val="F1F5F9"/>
+                          </a:solidFill>
+                          <a:latin typeface="Arial"/>
+                        </a:defRPr>
+                      </a:pPr>
+                      <a:r>
+                        <a:t>180.18 ms</a:t>
+                      </a:r>
+                    </a:p>
+                  </a:txBody>
+                  <a:tcPr/>
+                </a:tc>
+                <a:tc>
+                  <a:txBody>
+                    <a:bodyPr/>
+                    <a:lstStyle/>
+                    <a:p>
+                      <a:pPr>
+                        <a:defRPr sz="1200">
+                          <a:solidFill>
+                            <a:srgbClr val="F1F5F9"/>
+                          </a:solidFill>
+                          <a:latin typeface="Arial"/>
+                        </a:defRPr>
+                      </a:pPr>
+                      <a:r>
+                        <a:t>1.00x</a:t>
+                      </a:r>
+                    </a:p>
+                  </a:txBody>
+                  <a:tcPr/>
+                </a:tc>
+                <a:tc>
+                  <a:txBody>
+                    <a:bodyPr/>
+                    <a:lstStyle/>
+                    <a:p>
+                      <a:pPr>
+                        <a:defRPr sz="1200">
+                          <a:solidFill>
+                            <a:srgbClr val="F1F5F9"/>
+                          </a:solidFill>
+                          <a:latin typeface="Arial"/>
+                        </a:defRPr>
+                      </a:pPr>
+                      <a:r>
+                        <a:t>100.0%</a:t>
+                      </a:r>
+                    </a:p>
+                  </a:txBody>
+                  <a:tcPr/>
+                </a:tc>
+                <a:tc>
+                  <a:txBody>
+                    <a:bodyPr/>
+                    <a:lstStyle/>
+                    <a:p>
+                      <a:pPr>
+                        <a:defRPr sz="1200">
+                          <a:solidFill>
+                            <a:srgbClr val="F1F5F9"/>
+                          </a:solidFill>
+                          <a:latin typeface="Arial"/>
+                        </a:defRPr>
+                      </a:pPr>
+                      <a:r>
+                        <a:t>Baseline</a:t>
+                      </a:r>
+                    </a:p>
+                  </a:txBody>
+                  <a:tcPr/>
+                </a:tc>
+              </a:tr>
+              <a:tr h="822960">
+                <a:tc>
+                  <a:txBody>
+                    <a:bodyPr/>
+                    <a:lstStyle/>
+                    <a:p>
+                      <a:pPr>
+                        <a:defRPr sz="1200">
+                          <a:solidFill>
+                            <a:srgbClr val="F1F5F9"/>
+                          </a:solidFill>
+                          <a:latin typeface="Arial"/>
+                        </a:defRPr>
+                      </a:pPr>
+                      <a:r>
+                        <a:t>Parallel Grid</a:t>
+                      </a:r>
+                    </a:p>
+                  </a:txBody>
+                  <a:tcPr/>
+                </a:tc>
+                <a:tc>
+                  <a:txBody>
+                    <a:bodyPr/>
+                    <a:lstStyle/>
+                    <a:p>
+                      <a:pPr>
+                        <a:defRPr sz="1200">
+                          <a:solidFill>
+                            <a:srgbClr val="F1F5F9"/>
+                          </a:solidFill>
+                          <a:latin typeface="Arial"/>
+                        </a:defRPr>
+                      </a:pPr>
+                      <a:r>
+                        <a:t>2</a:t>
+                      </a:r>
+                    </a:p>
+                  </a:txBody>
+                  <a:tcPr/>
+                </a:tc>
+                <a:tc>
+                  <a:txBody>
+                    <a:bodyPr/>
+                    <a:lstStyle/>
+                    <a:p>
+                      <a:pPr>
+                        <a:defRPr sz="1200">
+                          <a:solidFill>
+                            <a:srgbClr val="F1F5F9"/>
+                          </a:solidFill>
+                          <a:latin typeface="Arial"/>
+                        </a:defRPr>
+                      </a:pPr>
+                      <a:r>
+                        <a:t>107.22 ms</a:t>
+                      </a:r>
+                    </a:p>
+                  </a:txBody>
+                  <a:tcPr/>
+                </a:tc>
+                <a:tc>
+                  <a:txBody>
+                    <a:bodyPr/>
+                    <a:lstStyle/>
+                    <a:p>
+                      <a:pPr>
+                        <a:defRPr sz="1200">
+                          <a:solidFill>
+                            <a:srgbClr val="F1F5F9"/>
+                          </a:solidFill>
+                          <a:latin typeface="Arial"/>
+                        </a:defRPr>
+                      </a:pPr>
+                      <a:r>
+                        <a:t>100.23 ms</a:t>
+                      </a:r>
+                    </a:p>
+                  </a:txBody>
+                  <a:tcPr/>
+                </a:tc>
+                <a:tc>
+                  <a:txBody>
+                    <a:bodyPr/>
+                    <a:lstStyle/>
+                    <a:p>
+                      <a:pPr>
+                        <a:defRPr sz="1200">
+                          <a:solidFill>
+                            <a:srgbClr val="F1F5F9"/>
+                          </a:solidFill>
+                          <a:latin typeface="Arial"/>
+                        </a:defRPr>
+                      </a:pPr>
+                      <a:r>
+                        <a:t>1.70x</a:t>
+                      </a:r>
+                    </a:p>
+                  </a:txBody>
+                  <a:tcPr/>
+                </a:tc>
+                <a:tc>
+                  <a:txBody>
+                    <a:bodyPr/>
+                    <a:lstStyle/>
+                    <a:p>
+                      <a:pPr>
+                        <a:defRPr sz="1200">
+                          <a:solidFill>
+                            <a:srgbClr val="F1F5F9"/>
+                          </a:solidFill>
+                          <a:latin typeface="Arial"/>
+                        </a:defRPr>
+                      </a:pPr>
+                      <a:r>
+                        <a:t>85.0%</a:t>
+                      </a:r>
+                    </a:p>
+                  </a:txBody>
+                  <a:tcPr/>
+                </a:tc>
+                <a:tc>
+                  <a:txBody>
+                    <a:bodyPr/>
+                    <a:lstStyle/>
+                    <a:p>
+                      <a:pPr>
+                        <a:defRPr sz="1200">
+                          <a:solidFill>
+                            <a:srgbClr val="F1F5F9"/>
+                          </a:solidFill>
+                          <a:latin typeface="Arial"/>
+                        </a:defRPr>
+                      </a:pPr>
+                      <a:r>
+                        <a:t>MATCH</a:t>
+                      </a:r>
+                    </a:p>
+                  </a:txBody>
+                  <a:tcPr/>
+                </a:tc>
+              </a:tr>
+              <a:tr h="822960">
+                <a:tc>
+                  <a:txBody>
+                    <a:bodyPr/>
+                    <a:lstStyle/>
+                    <a:p>
+                      <a:pPr>
+                        <a:defRPr sz="1200">
+                          <a:solidFill>
+                            <a:srgbClr val="F1F5F9"/>
+                          </a:solidFill>
+                          <a:latin typeface="Arial"/>
+                        </a:defRPr>
+                      </a:pPr>
+                      <a:r>
+                        <a:t>Parallel Grid</a:t>
+                      </a:r>
+                    </a:p>
+                  </a:txBody>
+                  <a:tcPr/>
+                </a:tc>
+                <a:tc>
+                  <a:txBody>
+                    <a:bodyPr/>
+                    <a:lstStyle/>
+                    <a:p>
+                      <a:pPr>
+                        <a:defRPr sz="1200">
+                          <a:solidFill>
+                            <a:srgbClr val="F1F5F9"/>
                           </a:solidFill>
                           <a:latin typeface="Arial"/>
                         </a:defRPr>
@@ -5181,13 +5445,13 @@
                       <a:pPr>
                         <a:defRPr sz="1200">
                           <a:solidFill>
-                            <a:srgbClr val="F8FAFC"/>
+                            <a:srgbClr val="F1F5F9"/>
                           </a:solidFill>
                           <a:latin typeface="Arial"/>
                         </a:defRPr>
                       </a:pPr>
                       <a:r>
-                        <a:t>8.616 ms</a:t>
+                        <a:t>99.34 ms</a:t>
                       </a:r>
                     </a:p>
                   </a:txBody>
@@ -5201,13 +5465,13 @@
                       <a:pPr>
                         <a:defRPr sz="1200">
                           <a:solidFill>
-                            <a:srgbClr val="F8FAFC"/>
+                            <a:srgbClr val="F1F5F9"/>
                           </a:solidFill>
                           <a:latin typeface="Arial"/>
                         </a:defRPr>
                       </a:pPr>
                       <a:r>
-                        <a:t>4.752 ms</a:t>
+                        <a:t>101.69 ms</a:t>
                       </a:r>
                     </a:p>
                   </a:txBody>
@@ -5221,13 +5485,13 @@
                       <a:pPr>
                         <a:defRPr sz="1200">
                           <a:solidFill>
-                            <a:srgbClr val="F8FAFC"/>
+                            <a:srgbClr val="F1F5F9"/>
                           </a:solidFill>
                           <a:latin typeface="Arial"/>
                         </a:defRPr>
                       </a:pPr>
                       <a:r>
-                        <a:t>1.81x</a:t>
+                        <a:t>1.84x</a:t>
                       </a:r>
                     </a:p>
                   </a:txBody>
@@ -5241,13 +5505,33 @@
                       <a:pPr>
                         <a:defRPr sz="1200">
                           <a:solidFill>
-                            <a:srgbClr val="F8FAFC"/>
+                            <a:srgbClr val="F1F5F9"/>
                           </a:solidFill>
                           <a:latin typeface="Arial"/>
                         </a:defRPr>
                       </a:pPr>
                       <a:r>
-                        <a:t>45.3%</a:t>
+                        <a:t>45.9%</a:t>
+                      </a:r>
+                    </a:p>
+                  </a:txBody>
+                  <a:tcPr/>
+                </a:tc>
+                <a:tc>
+                  <a:txBody>
+                    <a:bodyPr/>
+                    <a:lstStyle/>
+                    <a:p>
+                      <a:pPr>
+                        <a:defRPr sz="1200">
+                          <a:solidFill>
+                            <a:srgbClr val="F1F5F9"/>
+                          </a:solidFill>
+                          <a:latin typeface="Arial"/>
+                        </a:defRPr>
+                      </a:pPr>
+                      <a:r>
+                        <a:t>MATCH</a:t>
                       </a:r>
                     </a:p>
                   </a:txBody>
@@ -5263,13 +5547,13 @@
                       <a:pPr>
                         <a:defRPr sz="1200">
                           <a:solidFill>
-                            <a:srgbClr val="F8FAFC"/>
+                            <a:srgbClr val="F1F5F9"/>
                           </a:solidFill>
                           <a:latin typeface="Arial"/>
                         </a:defRPr>
                       </a:pPr>
                       <a:r>
-                        <a:t>50,000</a:t>
+                        <a:t>Parallel Grid</a:t>
                       </a:r>
                     </a:p>
                   </a:txBody>
@@ -5283,169 +5567,7 @@
                       <a:pPr>
                         <a:defRPr sz="1200">
                           <a:solidFill>
-                            <a:srgbClr val="F8FAFC"/>
-                          </a:solidFill>
-                          <a:latin typeface="Arial"/>
-                        </a:defRPr>
-                      </a:pPr>
-                      <a:r>
-                        <a:t>200</a:t>
-                      </a:r>
-                    </a:p>
-                  </a:txBody>
-                  <a:tcPr/>
-                </a:tc>
-                <a:tc>
-                  <a:txBody>
-                    <a:bodyPr/>
-                    <a:lstStyle/>
-                    <a:p>
-                      <a:pPr>
-                        <a:defRPr sz="1200">
-                          <a:solidFill>
-                            <a:srgbClr val="F8FAFC"/>
-                          </a:solidFill>
-                          <a:latin typeface="Arial"/>
-                        </a:defRPr>
-                      </a:pPr>
-                      <a:r>
-                        <a:t>4</a:t>
-                      </a:r>
-                    </a:p>
-                  </a:txBody>
-                  <a:tcPr/>
-                </a:tc>
-                <a:tc>
-                  <a:txBody>
-                    <a:bodyPr/>
-                    <a:lstStyle/>
-                    <a:p>
-                      <a:pPr>
-                        <a:defRPr sz="1200">
-                          <a:solidFill>
-                            <a:srgbClr val="F8FAFC"/>
-                          </a:solidFill>
-                          <a:latin typeface="Arial"/>
-                        </a:defRPr>
-                      </a:pPr>
-                      <a:r>
-                        <a:t>32.292 ms</a:t>
-                      </a:r>
-                    </a:p>
-                  </a:txBody>
-                  <a:tcPr/>
-                </a:tc>
-                <a:tc>
-                  <a:txBody>
-                    <a:bodyPr/>
-                    <a:lstStyle/>
-                    <a:p>
-                      <a:pPr>
-                        <a:defRPr sz="1200">
-                          <a:solidFill>
-                            <a:srgbClr val="F8FAFC"/>
-                          </a:solidFill>
-                          <a:latin typeface="Arial"/>
-                        </a:defRPr>
-                      </a:pPr>
-                      <a:r>
-                        <a:t>13.812 ms</a:t>
-                      </a:r>
-                    </a:p>
-                  </a:txBody>
-                  <a:tcPr/>
-                </a:tc>
-                <a:tc>
-                  <a:txBody>
-                    <a:bodyPr/>
-                    <a:lstStyle/>
-                    <a:p>
-                      <a:pPr>
-                        <a:defRPr sz="1200">
-                          <a:solidFill>
-                            <a:srgbClr val="F8FAFC"/>
-                          </a:solidFill>
-                          <a:latin typeface="Arial"/>
-                        </a:defRPr>
-                      </a:pPr>
-                      <a:r>
-                        <a:t>2.34x</a:t>
-                      </a:r>
-                    </a:p>
-                  </a:txBody>
-                  <a:tcPr/>
-                </a:tc>
-                <a:tc>
-                  <a:txBody>
-                    <a:bodyPr/>
-                    <a:lstStyle/>
-                    <a:p>
-                      <a:pPr>
-                        <a:defRPr sz="1200">
-                          <a:solidFill>
-                            <a:srgbClr val="F8FAFC"/>
-                          </a:solidFill>
-                          <a:latin typeface="Arial"/>
-                        </a:defRPr>
-                      </a:pPr>
-                      <a:r>
-                        <a:t>58.5%</a:t>
-                      </a:r>
-                    </a:p>
-                  </a:txBody>
-                  <a:tcPr/>
-                </a:tc>
-              </a:tr>
-              <a:tr h="822960">
-                <a:tc>
-                  <a:txBody>
-                    <a:bodyPr/>
-                    <a:lstStyle/>
-                    <a:p>
-                      <a:pPr>
-                        <a:defRPr sz="1200">
-                          <a:solidFill>
-                            <a:srgbClr val="F8FAFC"/>
-                          </a:solidFill>
-                          <a:latin typeface="Arial"/>
-                        </a:defRPr>
-                      </a:pPr>
-                      <a:r>
-                        <a:t>50,000</a:t>
-                      </a:r>
-                    </a:p>
-                  </a:txBody>
-                  <a:tcPr/>
-                </a:tc>
-                <a:tc>
-                  <a:txBody>
-                    <a:bodyPr/>
-                    <a:lstStyle/>
-                    <a:p>
-                      <a:pPr>
-                        <a:defRPr sz="1200">
-                          <a:solidFill>
-                            <a:srgbClr val="F8FAFC"/>
-                          </a:solidFill>
-                          <a:latin typeface="Arial"/>
-                        </a:defRPr>
-                      </a:pPr>
-                      <a:r>
-                        <a:t>200</a:t>
-                      </a:r>
-                    </a:p>
-                  </a:txBody>
-                  <a:tcPr/>
-                </a:tc>
-                <a:tc>
-                  <a:txBody>
-                    <a:bodyPr/>
-                    <a:lstStyle/>
-                    <a:p>
-                      <a:pPr>
-                        <a:defRPr sz="1200">
-                          <a:solidFill>
-                            <a:srgbClr val="F8FAFC"/>
+                            <a:srgbClr val="F1F5F9"/>
                           </a:solidFill>
                           <a:latin typeface="Arial"/>
                         </a:defRPr>
@@ -5465,13 +5587,13 @@
                       <a:pPr>
                         <a:defRPr sz="1200">
                           <a:solidFill>
-                            <a:srgbClr val="F8FAFC"/>
+                            <a:srgbClr val="F1F5F9"/>
                           </a:solidFill>
                           <a:latin typeface="Arial"/>
                         </a:defRPr>
                       </a:pPr>
                       <a:r>
-                        <a:t>41.890 ms</a:t>
+                        <a:t>53.48 ms</a:t>
                       </a:r>
                     </a:p>
                   </a:txBody>
@@ -5485,13 +5607,13 @@
                       <a:pPr>
                         <a:defRPr sz="1200">
                           <a:solidFill>
-                            <a:srgbClr val="F8FAFC"/>
+                            <a:srgbClr val="F1F5F9"/>
                           </a:solidFill>
                           <a:latin typeface="Arial"/>
                         </a:defRPr>
                       </a:pPr>
                       <a:r>
-                        <a:t>9.100 ms</a:t>
+                        <a:t>50.59 ms</a:t>
                       </a:r>
                     </a:p>
                   </a:txBody>
@@ -5505,13 +5627,13 @@
                       <a:pPr>
                         <a:defRPr sz="1200">
                           <a:solidFill>
-                            <a:srgbClr val="F8FAFC"/>
+                            <a:srgbClr val="F1F5F9"/>
                           </a:solidFill>
                           <a:latin typeface="Arial"/>
                         </a:defRPr>
                       </a:pPr>
                       <a:r>
-                        <a:t>4.60x</a:t>
+                        <a:t>3.41x</a:t>
                       </a:r>
                     </a:p>
                   </a:txBody>
@@ -5525,35 +5647,13 @@
                       <a:pPr>
                         <a:defRPr sz="1200">
                           <a:solidFill>
-                            <a:srgbClr val="F8FAFC"/>
+                            <a:srgbClr val="F1F5F9"/>
                           </a:solidFill>
                           <a:latin typeface="Arial"/>
                         </a:defRPr>
                       </a:pPr>
                       <a:r>
-                        <a:t>57.5%</a:t>
-                      </a:r>
-                    </a:p>
-                  </a:txBody>
-                  <a:tcPr/>
-                </a:tc>
-              </a:tr>
-              <a:tr h="822960">
-                <a:tc>
-                  <a:txBody>
-                    <a:bodyPr/>
-                    <a:lstStyle/>
-                    <a:p>
-                      <a:pPr>
-                        <a:defRPr sz="1200">
-                          <a:solidFill>
-                            <a:srgbClr val="F8FAFC"/>
-                          </a:solidFill>
-                          <a:latin typeface="Arial"/>
-                        </a:defRPr>
-                      </a:pPr>
-                      <a:r>
-                        <a:t>100,000</a:t>
+                        <a:t>42.6%</a:t>
                       </a:r>
                     </a:p>
                   </a:txBody>
@@ -5567,113 +5667,13 @@
                       <a:pPr>
                         <a:defRPr sz="1200">
                           <a:solidFill>
-                            <a:srgbClr val="F8FAFC"/>
+                            <a:srgbClr val="F1F5F9"/>
                           </a:solidFill>
                           <a:latin typeface="Arial"/>
                         </a:defRPr>
                       </a:pPr>
                       <a:r>
-                        <a:t>200</a:t>
-                      </a:r>
-                    </a:p>
-                  </a:txBody>
-                  <a:tcPr/>
-                </a:tc>
-                <a:tc>
-                  <a:txBody>
-                    <a:bodyPr/>
-                    <a:lstStyle/>
-                    <a:p>
-                      <a:pPr>
-                        <a:defRPr sz="1200">
-                          <a:solidFill>
-                            <a:srgbClr val="F8FAFC"/>
-                          </a:solidFill>
-                          <a:latin typeface="Arial"/>
-                        </a:defRPr>
-                      </a:pPr>
-                      <a:r>
-                        <a:t>8</a:t>
-                      </a:r>
-                    </a:p>
-                  </a:txBody>
-                  <a:tcPr/>
-                </a:tc>
-                <a:tc>
-                  <a:txBody>
-                    <a:bodyPr/>
-                    <a:lstStyle/>
-                    <a:p>
-                      <a:pPr>
-                        <a:defRPr sz="1200">
-                          <a:solidFill>
-                            <a:srgbClr val="F8FAFC"/>
-                          </a:solidFill>
-                          <a:latin typeface="Arial"/>
-                        </a:defRPr>
-                      </a:pPr>
-                      <a:r>
-                        <a:t>43.423 ms</a:t>
-                      </a:r>
-                    </a:p>
-                  </a:txBody>
-                  <a:tcPr/>
-                </a:tc>
-                <a:tc>
-                  <a:txBody>
-                    <a:bodyPr/>
-                    <a:lstStyle/>
-                    <a:p>
-                      <a:pPr>
-                        <a:defRPr sz="1200">
-                          <a:solidFill>
-                            <a:srgbClr val="F8FAFC"/>
-                          </a:solidFill>
-                          <a:latin typeface="Arial"/>
-                        </a:defRPr>
-                      </a:pPr>
-                      <a:r>
-                        <a:t>15.987 ms</a:t>
-                      </a:r>
-                    </a:p>
-                  </a:txBody>
-                  <a:tcPr/>
-                </a:tc>
-                <a:tc>
-                  <a:txBody>
-                    <a:bodyPr/>
-                    <a:lstStyle/>
-                    <a:p>
-                      <a:pPr>
-                        <a:defRPr sz="1200">
-                          <a:solidFill>
-                            <a:srgbClr val="F8FAFC"/>
-                          </a:solidFill>
-                          <a:latin typeface="Arial"/>
-                        </a:defRPr>
-                      </a:pPr>
-                      <a:r>
-                        <a:t>2.72x</a:t>
-                      </a:r>
-                    </a:p>
-                  </a:txBody>
-                  <a:tcPr/>
-                </a:tc>
-                <a:tc>
-                  <a:txBody>
-                    <a:bodyPr/>
-                    <a:lstStyle/>
-                    <a:p>
-                      <a:pPr>
-                        <a:defRPr sz="1200">
-                          <a:solidFill>
-                            <a:srgbClr val="F8FAFC"/>
-                          </a:solidFill>
-                          <a:latin typeface="Arial"/>
-                        </a:defRPr>
-                      </a:pPr>
-                      <a:r>
-                        <a:t>34.0%</a:t>
+                        <a:t>MATCH</a:t>
                       </a:r>
                     </a:p>
                   </a:txBody>
@@ -5698,7 +5698,7 @@
     <p:bg>
       <p:bgPr>
         <a:solidFill>
-          <a:srgbClr val="0F172A"/>
+          <a:srgbClr val="0B0F19"/>
         </a:solidFill>
         <a:effectLst/>
       </p:bgPr>
@@ -5771,7 +5771,7 @@
             <a:pPr>
               <a:defRPr sz="2400" b="1">
                 <a:solidFill>
-                  <a:srgbClr val="F8FAFC"/>
+                  <a:srgbClr val="F1F5F9"/>
                 </a:solidFill>
                 <a:latin typeface="Arial"/>
               </a:defRPr>
@@ -5784,7 +5784,7 @@
       </p:sp>
       <p:pic>
         <p:nvPicPr>
-          <p:cNvPr id="4" name="Picture 3" descr="dashboard_results.png"/>
+          <p:cNvPr id="4" name="Picture 3" descr="crowdflow_simulation.png"/>
           <p:cNvPicPr>
             <a:picLocks noChangeAspect="1"/>
           </p:cNvPicPr>
@@ -5835,17 +5835,17 @@
               </a:spcBef>
               <a:defRPr sz="1300">
                 <a:solidFill>
-                  <a:srgbClr val="F8FAFC"/>
+                  <a:srgbClr val="F1F5F9"/>
                 </a:solidFill>
                 <a:latin typeface="Arial"/>
               </a:defRPr>
             </a:pPr>
             <a:r>
-              <a:t>• Real-Time Dashboard:</a:t>
+              <a:t>• 2D Arena Visualization:</a:t>
             </a:r>
             <a:br/>
             <a:r>
-              <a:t>Launched with 'make web' on http://127.0.0.1:8080.</a:t>
+              <a:t>Real-time canvas rendering pedestrian streams, circular pillars, and doorway bottlenecks.</a:t>
             </a:r>
           </a:p>
           <a:p>
@@ -5855,17 +5855,17 @@
               </a:spcBef>
               <a:defRPr sz="1300">
                 <a:solidFill>
-                  <a:srgbClr val="F8FAFC"/>
+                  <a:srgbClr val="F1F5F9"/>
                 </a:solidFill>
                 <a:latin typeface="Arial"/>
               </a:defRPr>
             </a:pPr>
             <a:r>
-              <a:t>• True C Computation:</a:t>
+              <a:t>• Agent &amp; Heatmap Views:</a:t>
             </a:r>
             <a:br/>
             <a:r>
-              <a:t>Python backend delegates to compiled crowd_sim binary via subprocess. No JavaScript particle simulation.</a:t>
+              <a:t>Instant toggle between individual agent vectors and spatial congestion heatmaps.</a:t>
             </a:r>
           </a:p>
           <a:p>
@@ -5875,17 +5875,17 @@
               </a:spcBef>
               <a:defRPr sz="1300">
                 <a:solidFill>
-                  <a:srgbClr val="F8FAFC"/>
+                  <a:srgbClr val="F1F5F9"/>
                 </a:solidFill>
                 <a:latin typeface="Arial"/>
               </a:defRPr>
             </a:pPr>
             <a:r>
-              <a:t>• Canvas Spatial Heatmap:</a:t>
+              <a:t>• Multi-Thread Scaling:</a:t>
             </a:r>
             <a:br/>
             <a:r>
-              <a:t>C engine bins coordinates into an 80x30 density grid, rendered via HTML5 Canvas.</a:t>
+              <a:t>Interactive thread sweep with live strong-scaling performance bar charts.</a:t>
             </a:r>
           </a:p>
           <a:p>
@@ -5895,17 +5895,17 @@
               </a:spcBef>
               <a:defRPr sz="1300">
                 <a:solidFill>
-                  <a:srgbClr val="F8FAFC"/>
+                  <a:srgbClr val="F1F5F9"/>
                 </a:solidFill>
                 <a:latin typeface="Arial"/>
               </a:defRPr>
             </a:pPr>
             <a:r>
-              <a:t>• Status &amp; Validation:</a:t>
+              <a:t>• Analytics &amp; Export:</a:t>
             </a:r>
             <a:br/>
             <a:r>
-              <a:t>Instant visual reporting of MATCH and PASS verification badges.</a:t>
+              <a:t>Session history log and one-click CSV export for scientific benchmark reporting.</a:t>
             </a:r>
           </a:p>
         </p:txBody>
@@ -5924,7 +5924,7 @@
     <p:bg>
       <p:bgPr>
         <a:solidFill>
-          <a:srgbClr val="0F172A"/>
+          <a:srgbClr val="0B0F19"/>
         </a:solidFill>
         <a:effectLst/>
       </p:bgPr>
@@ -5997,13 +5997,13 @@
             <a:pPr>
               <a:defRPr sz="2400" b="1">
                 <a:solidFill>
-                  <a:srgbClr val="F8FAFC"/>
+                  <a:srgbClr val="F1F5F9"/>
                 </a:solidFill>
                 <a:latin typeface="Arial"/>
               </a:defRPr>
             </a:pPr>
             <a:r>
-              <a:t>Automated Verification Test Suite</a:t>
+              <a:t>Automated Verification &amp; Sanitizer Suite</a:t>
             </a:r>
           </a:p>
         </p:txBody>
@@ -6033,13 +6033,13 @@
             <a:pPr>
               <a:defRPr sz="1500">
                 <a:solidFill>
-                  <a:srgbClr val="F8FAFC"/>
+                  <a:srgbClr val="F1F5F9"/>
                 </a:solidFill>
                 <a:latin typeface="Arial"/>
               </a:defRPr>
             </a:pPr>
             <a:r>
-              <a:t>Executed via 'make test' with 15 automated test cases (100% Pass Rate):</a:t>
+              <a:t>27 Automated Regression Tests (100% Pass Rate via 'make test'):</a:t>
             </a:r>
           </a:p>
           <a:p>
@@ -6047,15 +6047,15 @@
               <a:spcBef>
                 <a:spcPts val="1000"/>
               </a:spcBef>
-              <a:defRPr sz="1450">
-                <a:solidFill>
-                  <a:srgbClr val="F8FAFC"/>
+              <a:defRPr sz="1400">
+                <a:solidFill>
+                  <a:srgbClr val="F1F5F9"/>
                 </a:solidFill>
                 <a:latin typeface="Arial"/>
               </a:defRPr>
             </a:pPr>
             <a:r>
-              <a:t>• Functional Baseline &amp; Micro-Workload: Default 1000-particle execution and edge case 10-particle simulation pass cleanly.</a:t>
+              <a:t>• Seed Determinism &amp; Invariants: Verified identical seeds produce bitwise identical states; validated zero NaN/inf values and zero boundary/obstacle escapes.</a:t>
             </a:r>
           </a:p>
           <a:p>
@@ -6063,15 +6063,15 @@
               <a:spcBef>
                 <a:spcPts val="1000"/>
               </a:spcBef>
-              <a:defRPr sz="1450">
-                <a:solidFill>
-                  <a:srgbClr val="F8FAFC"/>
+              <a:defRPr sz="1400">
+                <a:solidFill>
+                  <a:srgbClr val="F1F5F9"/>
                 </a:solidFill>
                 <a:latin typeface="Arial"/>
               </a:defRPr>
             </a:pPr>
             <a:r>
-              <a:t>• Multi-Thread Equivalence: Verified that 1, 4, and 8 OpenMP threads produce results identical to sequential baseline within 10^-9 precision.</a:t>
+              <a:t>• Spatial Grid Equivalence: Proved that spatial grid detected 100% identical neighbors to brute force and repulsive forces match within 10^-6.</a:t>
             </a:r>
           </a:p>
           <a:p>
@@ -6079,15 +6079,15 @@
               <a:spcBef>
                 <a:spcPts val="1000"/>
               </a:spcBef>
-              <a:defRPr sz="1450">
-                <a:solidFill>
-                  <a:srgbClr val="F8FAFC"/>
+              <a:defRPr sz="1400">
+                <a:solidFill>
+                  <a:srgbClr val="F1F5F9"/>
                 </a:solidFill>
                 <a:latin typeface="Arial"/>
               </a:defRPr>
             </a:pPr>
             <a:r>
-              <a:t>• Boundary Reflection Auditing: Audited that 100% of particles remain strictly within [0, 100] x [0, 40] boundaries.</a:t>
+              <a:t>• Multi-Thread Equivalence: Proved sequential matches OpenMP parallel across 1, 2, 4, 8 threads within 10^-6 precision.</a:t>
             </a:r>
           </a:p>
           <a:p>
@@ -6095,15 +6095,15 @@
               <a:spcBef>
                 <a:spcPts val="1000"/>
               </a:spcBef>
-              <a:defRPr sz="1450">
-                <a:solidFill>
-                  <a:srgbClr val="F8FAFC"/>
+              <a:defRPr sz="1400">
+                <a:solidFill>
+                  <a:srgbClr val="F1F5F9"/>
                 </a:solidFill>
                 <a:latin typeface="Arial"/>
               </a:defRPr>
             </a:pPr>
             <a:r>
-              <a:t>• Robust Input Rejection: Rejected zero particles, negative particles, non-numeric strings, zero steps, negative steps, zero threads, negative threads, and bogus options.</a:t>
+              <a:t>• Sanitizer Validation ('make test-sanitizer'): AddressSanitizer and UndefinedBehaviorSanitizer confirm zero memory leaks, zero buffer overflows, and zero undefined operations.</a:t>
             </a:r>
           </a:p>
         </p:txBody>
@@ -6122,7 +6122,7 @@
     <p:bg>
       <p:bgPr>
         <a:solidFill>
-          <a:srgbClr val="0F172A"/>
+          <a:srgbClr val="0B0F19"/>
         </a:solidFill>
         <a:effectLst/>
       </p:bgPr>
@@ -6195,13 +6195,13 @@
             <a:pPr>
               <a:defRPr sz="2400" b="1">
                 <a:solidFill>
-                  <a:srgbClr val="F8FAFC"/>
+                  <a:srgbClr val="F1F5F9"/>
                 </a:solidFill>
                 <a:latin typeface="Arial"/>
               </a:defRPr>
             </a:pPr>
             <a:r>
-              <a:t>Applications, Limitations &amp; Future Scope</a:t>
+              <a:t>Practical Relevance &amp; Future Enhancements</a:t>
             </a:r>
           </a:p>
         </p:txBody>
@@ -6235,13 +6235,13 @@
               </a:spcBef>
               <a:defRPr sz="1500">
                 <a:solidFill>
-                  <a:srgbClr val="F8FAFC"/>
+                  <a:srgbClr val="F1F5F9"/>
                 </a:solidFill>
                 <a:latin typeface="Arial"/>
               </a:defRPr>
             </a:pPr>
             <a:r>
-              <a:t>• Real-World Applications: Molecular dynamics (Brownian motion), game entity updates, Monte Carlo photon simulation, robotics particle filtering.</a:t>
+              <a:t>• Real-World Applications: Transit terminal design, sports stadium evacuation, architectural egress planning, robotics swarm simulation.</a:t>
             </a:r>
           </a:p>
           <a:p>
@@ -6251,13 +6251,13 @@
               </a:spcBef>
               <a:defRPr sz="1500">
                 <a:solidFill>
-                  <a:srgbClr val="F8FAFC"/>
+                  <a:srgbClr val="F1F5F9"/>
                 </a:solidFill>
                 <a:latin typeface="Arial"/>
               </a:defRPr>
             </a:pPr>
             <a:r>
-              <a:t>• Current Limitations: Educational point-mass model; zero inter-particle collisions; single-node SMP architecture (no MPI / CUDA).</a:t>
+              <a:t>• Future Scope — SIMD Vectorization: Add #pragma omp simd to vectorize inner neighbor loops using AVX-512 instructions (2x-4x single-core boost).</a:t>
             </a:r>
           </a:p>
           <a:p>
@@ -6267,13 +6267,13 @@
               </a:spcBef>
               <a:defRPr sz="1500">
                 <a:solidFill>
-                  <a:srgbClr val="F8FAFC"/>
+                  <a:srgbClr val="F1F5F9"/>
                 </a:solidFill>
                 <a:latin typeface="Arial"/>
               </a:defRPr>
             </a:pPr>
             <a:r>
-              <a:t>• Future Scope — Spatial Cell Lists: Partition the 2D area into grid bins so particles only check adjacent neighbours, enabling O(N) physical collisions without destroying parallel scaling.</a:t>
+              <a:t>• Future Scope — Hybrid MPI + OpenMP: Spatial domain decomposition across distributed cluster nodes with MPI, while OpenMP accelerates local cores.</a:t>
             </a:r>
           </a:p>
           <a:p>
@@ -6283,13 +6283,13 @@
               </a:spcBef>
               <a:defRPr sz="1500">
                 <a:solidFill>
-                  <a:srgbClr val="F8FAFC"/>
+                  <a:srgbClr val="F1F5F9"/>
                 </a:solidFill>
                 <a:latin typeface="Arial"/>
               </a:defRPr>
             </a:pPr>
             <a:r>
-              <a:t>• Future Scope — Hybrid MPI + OpenMP: Decompose spatial domains across multiple networked cluster nodes with MPI, while OpenMP accelerates local cores.</a:t>
+              <a:t>• Future Scope — NavMesh Pathfinding: Precomputed A* navigation meshes for complex floorplans with multi-room corridors.</a:t>
             </a:r>
           </a:p>
         </p:txBody>
@@ -6308,7 +6308,7 @@
     <p:bg>
       <p:bgPr>
         <a:solidFill>
-          <a:srgbClr val="0F172A"/>
+          <a:srgbClr val="0B0F19"/>
         </a:solidFill>
         <a:effectLst/>
       </p:bgPr>
@@ -6361,13 +6361,13 @@
               </a:spcBef>
               <a:defRPr sz="2800" b="1">
                 <a:solidFill>
-                  <a:srgbClr val="F8FAFC"/>
+                  <a:srgbClr val="F1F5F9"/>
                 </a:solidFill>
                 <a:latin typeface="Arial"/>
               </a:defRPr>
             </a:pPr>
             <a:r>
-              <a:t>CrowdSim: Parallel Computing Mini-Project</a:t>
+              <a:t>CrowdFlow: Parallel Computing Mini-Project</a:t>
             </a:r>
           </a:p>
           <a:p>
@@ -6375,7 +6375,7 @@
               <a:spcBef>
                 <a:spcPts val="1000"/>
               </a:spcBef>
-              <a:defRPr sz="1600">
+              <a:defRPr sz="1550">
                 <a:solidFill>
                   <a:srgbClr val="94A3B8"/>
                 </a:solidFill>
@@ -6383,7 +6383,7 @@
               </a:defRPr>
             </a:pPr>
             <a:r>
-              <a:t>✓ Demonstrated up to 4.60x Speedup using OpenMP shared-memory directives on multi-core CPUs.</a:t>
+              <a:t>✓ Evolved particle movement into continuous crowd dynamics with goal steering and social separation.</a:t>
             </a:r>
           </a:p>
           <a:p>
@@ -6391,7 +6391,7 @@
               <a:spcBef>
                 <a:spcPts val="1000"/>
               </a:spcBef>
-              <a:defRPr sz="1600">
+              <a:defRPr sz="1550">
                 <a:solidFill>
                   <a:srgbClr val="94A3B8"/>
                 </a:solidFill>
@@ -6399,7 +6399,7 @@
               </a:defRPr>
             </a:pPr>
             <a:r>
-              <a:t>✓ Proved complete numerical equivalence (MATCH within 10^-9) between sequential and parallel implementations.</a:t>
+              <a:t>✓ Overcame O(N²) pairwise complexity using an O(N) uniform spatial partitioning grid (&gt; 96% check reduction).</a:t>
             </a:r>
           </a:p>
           <a:p>
@@ -6407,7 +6407,7 @@
               <a:spcBef>
                 <a:spcPts val="1000"/>
               </a:spcBef>
-              <a:defRPr sz="1600">
+              <a:defRPr sz="1550">
                 <a:solidFill>
                   <a:srgbClr val="94A3B8"/>
                 </a:solidFill>
@@ -6415,7 +6415,7 @@
               </a:defRPr>
             </a:pPr>
             <a:r>
-              <a:t>✓ Successfully mapped academic concepts from VTU Modules 1, 2, and 4 into a working C systems application.</a:t>
+              <a:t>✓ Implemented a race-free double-buffered OpenMP architecture achieving up to 3.41x parallel speedup.</a:t>
             </a:r>
           </a:p>
           <a:p>
@@ -6423,7 +6423,7 @@
               <a:spcBef>
                 <a:spcPts val="1000"/>
               </a:spcBef>
-              <a:defRPr sz="1600">
+              <a:defRPr sz="1550">
                 <a:solidFill>
                   <a:srgbClr val="94A3B8"/>
                 </a:solidFill>
@@ -6431,7 +6431,23 @@
               </a:defRPr>
             </a:pPr>
             <a:r>
-              <a:t>✓ Delivered a zero-dependency web dashboard for accessible, interactive live demonstration.</a:t>
+              <a:t>✓ Demonstrated 44% higher efficiency under dynamic scheduling for crowded doorway bottlenecks.</a:t>
+            </a:r>
+          </a:p>
+          <a:p>
+            <a:pPr>
+              <a:spcBef>
+                <a:spcPts val="1000"/>
+              </a:spcBef>
+              <a:defRPr sz="1550">
+                <a:solidFill>
+                  <a:srgbClr val="94A3B8"/>
+                </a:solidFill>
+                <a:latin typeface="Arial"/>
+              </a:defRPr>
+            </a:pPr>
+            <a:r>
+              <a:t>✓ Verified 100% correctness across 27 automated tests and delivered an interactive web dashboard.</a:t>
             </a:r>
           </a:p>
           <a:p>
@@ -6467,7 +6483,7 @@
     <p:bg>
       <p:bgPr>
         <a:solidFill>
-          <a:srgbClr val="0F172A"/>
+          <a:srgbClr val="0B0F19"/>
         </a:solidFill>
         <a:effectLst/>
       </p:bgPr>
@@ -6540,13 +6556,13 @@
             <a:pPr>
               <a:defRPr sz="2400" b="1">
                 <a:solidFill>
-                  <a:srgbClr val="F8FAFC"/>
+                  <a:srgbClr val="F1F5F9"/>
                 </a:solidFill>
                 <a:latin typeface="Arial"/>
               </a:defRPr>
             </a:pPr>
             <a:r>
-              <a:t>Problem Statement: The Single-Core Bottleneck</a:t>
+              <a:t>Problem Statement: The O(N²) Neighbor Bottleneck</a:t>
             </a:r>
           </a:p>
         </p:txBody>
@@ -6580,13 +6596,13 @@
               </a:spcBef>
               <a:defRPr sz="1600">
                 <a:solidFill>
-                  <a:srgbClr val="F8FAFC"/>
+                  <a:srgbClr val="F1F5F9"/>
                 </a:solidFill>
                 <a:latin typeface="Arial"/>
               </a:defRPr>
             </a:pPr>
             <a:r>
-              <a:t>• Computational Physics Scaling: Simulating dynamic particles requires repeatedly updating positions over discrete time steps. Total workload scales as O(N * S).</a:t>
+              <a:t>• Real Crowd Physics: Unlike independent particles, crowd agents must continuously avoid neighbors and physical obstacles via social separation forces.</a:t>
             </a:r>
           </a:p>
           <a:p>
@@ -6596,13 +6612,13 @@
               </a:spcBef>
               <a:defRPr sz="1600">
                 <a:solidFill>
-                  <a:srgbClr val="F8FAFC"/>
+                  <a:srgbClr val="F1F5F9"/>
                 </a:solidFill>
                 <a:latin typeface="Arial"/>
               </a:defRPr>
             </a:pPr>
             <a:r>
-              <a:t>• Massive Arithmetic Workload: Updating 100,000 particles over 500 steps requires 50,000,000 state calculations, creating a severe CPU bottleneck.</a:t>
+              <a:t>• The O(N²) Algorithmic Wall: Naive pairwise distance checking requires N*(N-1)/2 calculations per step (1.25 billion distance checks at 50,000 agents).</a:t>
             </a:r>
           </a:p>
           <a:p>
@@ -6612,13 +6628,13 @@
               </a:spcBef>
               <a:defRPr sz="1600">
                 <a:solidFill>
-                  <a:srgbClr val="F8FAFC"/>
+                  <a:srgbClr val="F1F5F9"/>
                 </a:solidFill>
                 <a:latin typeface="Arial"/>
               </a:defRPr>
             </a:pPr>
             <a:r>
-              <a:t>• Idle Modern Hardware: Sequential execution utilizes only 1 core (~8% on 12-core CPU), leaving 90%+ of hardware compute capacity idle.</a:t>
+              <a:t>• The Multi-Core Imperative: Sequential single-core execution leaves up to 90% of modern multi-core computing power idle.</a:t>
             </a:r>
           </a:p>
           <a:p>
@@ -6628,13 +6644,13 @@
               </a:spcBef>
               <a:defRPr sz="1600">
                 <a:solidFill>
-                  <a:srgbClr val="F8FAFC"/>
+                  <a:srgbClr val="F1F5F9"/>
                 </a:solidFill>
                 <a:latin typeface="Arial"/>
               </a:defRPr>
             </a:pPr>
             <a:r>
-              <a:t>• Core Engineering Question: Can independent particle updates be cleanly parallelized using OpenMP directives without introducing race conditions or excessive synchronization overhead?</a:t>
+              <a:t>• Core Engineering Goal: Combine an O(N) spatial partitioning grid with multi-threaded OpenMP scheduling to achieve high throughput with verified numerical correctness.</a:t>
             </a:r>
           </a:p>
         </p:txBody>
@@ -6653,7 +6669,7 @@
     <p:bg>
       <p:bgPr>
         <a:solidFill>
-          <a:srgbClr val="0F172A"/>
+          <a:srgbClr val="0B0F19"/>
         </a:solidFill>
         <a:effectLst/>
       </p:bgPr>
@@ -6726,7 +6742,7 @@
             <a:pPr>
               <a:defRPr sz="2400" b="1">
                 <a:solidFill>
-                  <a:srgbClr val="F8FAFC"/>
+                  <a:srgbClr val="F1F5F9"/>
                 </a:solidFill>
                 <a:latin typeface="Arial"/>
               </a:defRPr>
@@ -6766,13 +6782,13 @@
               </a:spcBef>
               <a:defRPr sz="1550">
                 <a:solidFill>
-                  <a:srgbClr val="F8FAFC"/>
+                  <a:srgbClr val="F1F5F9"/>
                 </a:solidFill>
                 <a:latin typeface="Arial"/>
               </a:defRPr>
             </a:pPr>
             <a:r>
-              <a:t>• 1. 2D Particle Motion &amp; Wall Reflection: Model point particles in a 100x40 bounded rectangular environment with robust periodic folding reflection.</a:t>
+              <a:t>• 1. Continuous Crowd Dynamics: Implement goal relaxation steering, social separation forces, and obstacle avoidance in C11.</a:t>
             </a:r>
           </a:p>
           <a:p>
@@ -6782,13 +6798,13 @@
               </a:spcBef>
               <a:defRPr sz="1550">
                 <a:solidFill>
-                  <a:srgbClr val="F8FAFC"/>
+                  <a:srgbClr val="F1F5F9"/>
                 </a:solidFill>
                 <a:latin typeface="Arial"/>
               </a:defRPr>
             </a:pPr>
             <a:r>
-              <a:t>• 2. Dual Computational Engines: Implement a single-threaded sequential reference version and an OpenMP parallel version.</a:t>
+              <a:t>• 2. Spatial Partitioning Grid: Reduce neighbor candidate checks from O(N²) to O(N) using uniform spatial hashing (Forward-Star flat arrays).</a:t>
             </a:r>
           </a:p>
           <a:p>
@@ -6798,13 +6814,13 @@
               </a:spcBef>
               <a:defRPr sz="1550">
                 <a:solidFill>
-                  <a:srgbClr val="F8FAFC"/>
+                  <a:srgbClr val="F1F5F9"/>
                 </a:solidFill>
                 <a:latin typeface="Arial"/>
               </a:defRPr>
             </a:pPr>
             <a:r>
-              <a:t>• 3. Performance Measurement: Measure high-resolution wall-clock times; calculate Speedup (S = T_seq / T_par) and Parallel Efficiency (E = S / P).</a:t>
+              <a:t>• 3. Race-Free OpenMP Engine: Implement a double-buffered two-phase commit design eliminating data races without mutex locks.</a:t>
             </a:r>
           </a:p>
           <a:p>
@@ -6814,13 +6830,13 @@
               </a:spcBef>
               <a:defRPr sz="1550">
                 <a:solidFill>
-                  <a:srgbClr val="F8FAFC"/>
+                  <a:srgbClr val="F1F5F9"/>
                 </a:solidFill>
                 <a:latin typeface="Arial"/>
               </a:defRPr>
             </a:pPr>
             <a:r>
-              <a:t>• 4. Strict Mathematical Verification: Prove parallel correctness by validating that all final particle states match the sequential baseline within 10^-9 tolerance.</a:t>
+              <a:t>• 4. Scheduling Policy Analysis: Benchmark static, dynamic, and guided scheduling under crowded bottleneck scenarios.</a:t>
             </a:r>
           </a:p>
           <a:p>
@@ -6830,13 +6846,13 @@
               </a:spcBef>
               <a:defRPr sz="1550">
                 <a:solidFill>
-                  <a:srgbClr val="F8FAFC"/>
+                  <a:srgbClr val="F1F5F9"/>
                 </a:solidFill>
                 <a:latin typeface="Arial"/>
               </a:defRPr>
             </a:pPr>
             <a:r>
-              <a:t>• 5. Interactive Web Demonstration: Connect native C engine to an accessible browser dashboard with an HTML5 Canvas spatial density heatmap.</a:t>
+              <a:t>• 5. Verification &amp; Dashboard: Validate 100% equivalence between sequential and parallel runs, verified by 27 automated tests and an interactive web dashboard.</a:t>
             </a:r>
           </a:p>
         </p:txBody>
@@ -6855,7 +6871,7 @@
     <p:bg>
       <p:bgPr>
         <a:solidFill>
-          <a:srgbClr val="0F172A"/>
+          <a:srgbClr val="0B0F19"/>
         </a:solidFill>
         <a:effectLst/>
       </p:bgPr>
@@ -6928,13 +6944,13 @@
             <a:pPr>
               <a:defRPr sz="2400" b="1">
                 <a:solidFill>
-                  <a:srgbClr val="F8FAFC"/>
+                  <a:srgbClr val="F1F5F9"/>
                 </a:solidFill>
                 <a:latin typeface="Arial"/>
               </a:defRPr>
             </a:pPr>
             <a:r>
-              <a:t>Theoretical Background: Shared-Memory Architecture</a:t>
+              <a:t>Concurrency Model: Race-Free Double Buffering</a:t>
             </a:r>
           </a:p>
         </p:txBody>
@@ -6968,13 +6984,13 @@
               </a:spcBef>
               <a:defRPr sz="1550">
                 <a:solidFill>
-                  <a:srgbClr val="F8FAFC"/>
+                  <a:srgbClr val="F1F5F9"/>
                 </a:solidFill>
                 <a:latin typeface="Arial"/>
               </a:defRPr>
             </a:pPr>
             <a:r>
-              <a:t>• MIMD Architecture (Multiple Instruction, Multiple Data): Modern multi-core processors execute asynchronous instruction streams on disjoint data streams concurrently.</a:t>
+              <a:t>• The Shared-Memory Concurrency Hazard: When threads read neighbor positions to compute repulsive forces, modifying positions in-place causes read-after-write (RAW) race conditions.</a:t>
             </a:r>
           </a:p>
           <a:p>
@@ -6984,13 +7000,13 @@
               </a:spcBef>
               <a:defRPr sz="1550">
                 <a:solidFill>
-                  <a:srgbClr val="F8FAFC"/>
+                  <a:srgbClr val="F1F5F9"/>
                 </a:solidFill>
                 <a:latin typeface="Arial"/>
               </a:defRPr>
             </a:pPr>
             <a:r>
-              <a:t>• Shared-Memory Programming Model: All threads execute within the same process virtual address space, accessing common heap memory with zero network latency.</a:t>
+              <a:t>• Phase 1 — Parallel Compute (Immutable Reads): All threads read exclusively from current_agents. Each thread writes its updated state strictly to its assigned index in next_agents.</a:t>
             </a:r>
           </a:p>
           <a:p>
@@ -7000,13 +7016,13 @@
               </a:spcBef>
               <a:defRPr sz="1550">
                 <a:solidFill>
-                  <a:srgbClr val="F8FAFC"/>
+                  <a:srgbClr val="F1F5F9"/>
                 </a:solidFill>
                 <a:latin typeface="Arial"/>
               </a:defRPr>
             </a:pPr>
             <a:r>
-              <a:t>• Data-Level Parallelism (Embarrassing Parallelism): Because particle i's movement is independent of particle j during any time step, the inner loop requires zero thread-to-thread communication.</a:t>
+              <a:t>• Disjoint Memory Writes: Because thread k writes strictly to next_agents[i], memory writes are completely disjoint. Zero locks or critical sections required!</a:t>
             </a:r>
           </a:p>
           <a:p>
@@ -7016,13 +7032,13 @@
               </a:spcBef>
               <a:defRPr sz="1550">
                 <a:solidFill>
-                  <a:srgbClr val="F8FAFC"/>
+                  <a:srgbClr val="F1F5F9"/>
                 </a:solidFill>
                 <a:latin typeface="Arial"/>
               </a:defRPr>
             </a:pPr>
             <a:r>
-              <a:t>• Fork-Join Execution Model: The master thread forks worker threads upon entering #pragma omp parallel, distributes loop iterations, and synchronizes at an implicit barrier.</a:t>
+              <a:t>• Phase 2 — Commit (O(1) Pointer Swap): At the time-step barrier, pointers are swapped atomically in O(1) time: current_agents &lt;-&gt; next_agents.</a:t>
             </a:r>
           </a:p>
         </p:txBody>
@@ -7041,7 +7057,7 @@
     <p:bg>
       <p:bgPr>
         <a:solidFill>
-          <a:srgbClr val="0F172A"/>
+          <a:srgbClr val="0B0F19"/>
         </a:solidFill>
         <a:effectLst/>
       </p:bgPr>
@@ -7114,366 +7130,137 @@
             <a:pPr>
               <a:defRPr sz="2400" b="1">
                 <a:solidFill>
-                  <a:srgbClr val="F8FAFC"/>
+                  <a:srgbClr val="F1F5F9"/>
                 </a:solidFill>
                 <a:latin typeface="Arial"/>
               </a:defRPr>
             </a:pPr>
             <a:r>
-              <a:t>Comparison: Sequential vs Proposed OpenMP Approach</a:t>
-            </a:r>
-          </a:p>
-        </p:txBody>
-      </p:sp>
-      <p:graphicFrame>
-        <p:nvGraphicFramePr>
-          <p:cNvPr id="4" name="Table 3"/>
-          <p:cNvGraphicFramePr>
-            <a:graphicFrameLocks noGrp="1"/>
-          </p:cNvGraphicFramePr>
+              <a:t>Modular System Architecture</a:t>
+            </a:r>
+          </a:p>
+        </p:txBody>
+      </p:sp>
+      <p:sp>
+        <p:nvSpPr>
+          <p:cNvPr id="4" name="TextBox 3"/>
+          <p:cNvSpPr txBox="1"/>
           <p:nvPr/>
-        </p:nvGraphicFramePr>
-        <p:xfrm>
-          <a:off x="731520" y="1645920"/>
-          <a:ext cx="10698480" cy="4114800"/>
-        </p:xfrm>
-        <a:graphic>
-          <a:graphicData uri="http://schemas.openxmlformats.org/drawingml/2006/table">
-            <a:tbl>
-              <a:tblPr firstRow="1" bandRow="1">
-                <a:tableStyleId>{5C22544A-7EE6-4342-B048-85BDC9FD1C3A}</a:tableStyleId>
-              </a:tblPr>
-              <a:tblGrid>
-                <a:gridCol w="2926080"/>
-                <a:gridCol w="3840480"/>
-                <a:gridCol w="3931920"/>
-              </a:tblGrid>
-              <a:tr h="822960">
-                <a:tc>
-                  <a:txBody>
-                    <a:bodyPr/>
-                    <a:lstStyle/>
-                    <a:p>
-                      <a:pPr>
-                        <a:defRPr sz="1400" b="1">
-                          <a:solidFill>
-                            <a:srgbClr val="38BDF8"/>
-                          </a:solidFill>
-                          <a:latin typeface="Arial"/>
-                        </a:defRPr>
-                      </a:pPr>
-                      <a:r>
-                        <a:t>Feature</a:t>
-                      </a:r>
-                    </a:p>
-                  </a:txBody>
-                  <a:tcPr>
-                    <a:solidFill>
-                      <a:srgbClr val="1E293B"/>
-                    </a:solidFill>
-                  </a:tcPr>
-                </a:tc>
-                <a:tc>
-                  <a:txBody>
-                    <a:bodyPr/>
-                    <a:lstStyle/>
-                    <a:p>
-                      <a:pPr>
-                        <a:defRPr sz="1400" b="1">
-                          <a:solidFill>
-                            <a:srgbClr val="38BDF8"/>
-                          </a:solidFill>
-                          <a:latin typeface="Arial"/>
-                        </a:defRPr>
-                      </a:pPr>
-                      <a:r>
-                        <a:t>Traditional Sequential Approach</a:t>
-                      </a:r>
-                    </a:p>
-                  </a:txBody>
-                  <a:tcPr>
-                    <a:solidFill>
-                      <a:srgbClr val="1E293B"/>
-                    </a:solidFill>
-                  </a:tcPr>
-                </a:tc>
-                <a:tc>
-                  <a:txBody>
-                    <a:bodyPr/>
-                    <a:lstStyle/>
-                    <a:p>
-                      <a:pPr>
-                        <a:defRPr sz="1400" b="1">
-                          <a:solidFill>
-                            <a:srgbClr val="38BDF8"/>
-                          </a:solidFill>
-                          <a:latin typeface="Arial"/>
-                        </a:defRPr>
-                      </a:pPr>
-                      <a:r>
-                        <a:t>CrowdSim OpenMP Approach</a:t>
-                      </a:r>
-                    </a:p>
-                  </a:txBody>
-                  <a:tcPr>
-                    <a:solidFill>
-                      <a:srgbClr val="1E293B"/>
-                    </a:solidFill>
-                  </a:tcPr>
-                </a:tc>
-              </a:tr>
-              <a:tr h="822960">
-                <a:tc>
-                  <a:txBody>
-                    <a:bodyPr/>
-                    <a:lstStyle/>
-                    <a:p>
-                      <a:pPr>
-                        <a:defRPr sz="1300">
-                          <a:solidFill>
-                            <a:srgbClr val="F8FAFC"/>
-                          </a:solidFill>
-                          <a:latin typeface="Arial"/>
-                        </a:defRPr>
-                      </a:pPr>
-                      <a:r>
-                        <a:t>Hardware Utilization</a:t>
-                      </a:r>
-                    </a:p>
-                  </a:txBody>
-                  <a:tcPr/>
-                </a:tc>
-                <a:tc>
-                  <a:txBody>
-                    <a:bodyPr/>
-                    <a:lstStyle/>
-                    <a:p>
-                      <a:pPr>
-                        <a:defRPr sz="1300">
-                          <a:solidFill>
-                            <a:srgbClr val="F8FAFC"/>
-                          </a:solidFill>
-                          <a:latin typeface="Arial"/>
-                        </a:defRPr>
-                      </a:pPr>
-                      <a:r>
-                        <a:t>Single core active (~8% on 12-core system)</a:t>
-                      </a:r>
-                    </a:p>
-                  </a:txBody>
-                  <a:tcPr/>
-                </a:tc>
-                <a:tc>
-                  <a:txBody>
-                    <a:bodyPr/>
-                    <a:lstStyle/>
-                    <a:p>
-                      <a:pPr>
-                        <a:defRPr sz="1300">
-                          <a:solidFill>
-                            <a:srgbClr val="F8FAFC"/>
-                          </a:solidFill>
-                          <a:latin typeface="Arial"/>
-                        </a:defRPr>
-                      </a:pPr>
-                      <a:r>
-                        <a:t>All allocated CPU cores active (100% core load)</a:t>
-                      </a:r>
-                    </a:p>
-                  </a:txBody>
-                  <a:tcPr/>
-                </a:tc>
-              </a:tr>
-              <a:tr h="822960">
-                <a:tc>
-                  <a:txBody>
-                    <a:bodyPr/>
-                    <a:lstStyle/>
-                    <a:p>
-                      <a:pPr>
-                        <a:defRPr sz="1300">
-                          <a:solidFill>
-                            <a:srgbClr val="F8FAFC"/>
-                          </a:solidFill>
-                          <a:latin typeface="Arial"/>
-                        </a:defRPr>
-                      </a:pPr>
-                      <a:r>
-                        <a:t>Execution Time (50k P, 200 S)</a:t>
-                      </a:r>
-                    </a:p>
-                  </a:txBody>
-                  <a:tcPr/>
-                </a:tc>
-                <a:tc>
-                  <a:txBody>
-                    <a:bodyPr/>
-                    <a:lstStyle/>
-                    <a:p>
-                      <a:pPr>
-                        <a:defRPr sz="1300">
-                          <a:solidFill>
-                            <a:srgbClr val="F8FAFC"/>
-                          </a:solidFill>
-                          <a:latin typeface="Arial"/>
-                        </a:defRPr>
-                      </a:pPr>
-                      <a:r>
-                        <a:t>41.890 ms</a:t>
-                      </a:r>
-                    </a:p>
-                  </a:txBody>
-                  <a:tcPr/>
-                </a:tc>
-                <a:tc>
-                  <a:txBody>
-                    <a:bodyPr/>
-                    <a:lstStyle/>
-                    <a:p>
-                      <a:pPr>
-                        <a:defRPr sz="1300">
-                          <a:solidFill>
-                            <a:srgbClr val="F8FAFC"/>
-                          </a:solidFill>
-                          <a:latin typeface="Arial"/>
-                        </a:defRPr>
-                      </a:pPr>
-                      <a:r>
-                        <a:t>9.100 ms (4.60x Speedup)</a:t>
-                      </a:r>
-                    </a:p>
-                  </a:txBody>
-                  <a:tcPr/>
-                </a:tc>
-              </a:tr>
-              <a:tr h="822960">
-                <a:tc>
-                  <a:txBody>
-                    <a:bodyPr/>
-                    <a:lstStyle/>
-                    <a:p>
-                      <a:pPr>
-                        <a:defRPr sz="1300">
-                          <a:solidFill>
-                            <a:srgbClr val="F8FAFC"/>
-                          </a:solidFill>
-                          <a:latin typeface="Arial"/>
-                        </a:defRPr>
-                      </a:pPr>
-                      <a:r>
-                        <a:t>Scalability</a:t>
-                      </a:r>
-                    </a:p>
-                  </a:txBody>
-                  <a:tcPr/>
-                </a:tc>
-                <a:tc>
-                  <a:txBody>
-                    <a:bodyPr/>
-                    <a:lstStyle/>
-                    <a:p>
-                      <a:pPr>
-                        <a:defRPr sz="1300">
-                          <a:solidFill>
-                            <a:srgbClr val="F8FAFC"/>
-                          </a:solidFill>
-                          <a:latin typeface="Arial"/>
-                        </a:defRPr>
-                      </a:pPr>
-                      <a:r>
-                        <a:t>Bottlenecked on single-thread clock speed</a:t>
-                      </a:r>
-                    </a:p>
-                  </a:txBody>
-                  <a:tcPr/>
-                </a:tc>
-                <a:tc>
-                  <a:txBody>
-                    <a:bodyPr/>
-                    <a:lstStyle/>
-                    <a:p>
-                      <a:pPr>
-                        <a:defRPr sz="1300">
-                          <a:solidFill>
-                            <a:srgbClr val="F8FAFC"/>
-                          </a:solidFill>
-                          <a:latin typeface="Arial"/>
-                        </a:defRPr>
-                      </a:pPr>
-                      <a:r>
-                        <a:t>Scales with physical multi-core hardware threads</a:t>
-                      </a:r>
-                    </a:p>
-                  </a:txBody>
-                  <a:tcPr/>
-                </a:tc>
-              </a:tr>
-              <a:tr h="822960">
-                <a:tc>
-                  <a:txBody>
-                    <a:bodyPr/>
-                    <a:lstStyle/>
-                    <a:p>
-                      <a:pPr>
-                        <a:defRPr sz="1300">
-                          <a:solidFill>
-                            <a:srgbClr val="F8FAFC"/>
-                          </a:solidFill>
-                          <a:latin typeface="Arial"/>
-                        </a:defRPr>
-                      </a:pPr>
-                      <a:r>
-                        <a:t>Demonstration Interface</a:t>
-                      </a:r>
-                    </a:p>
-                  </a:txBody>
-                  <a:tcPr/>
-                </a:tc>
-                <a:tc>
-                  <a:txBody>
-                    <a:bodyPr/>
-                    <a:lstStyle/>
-                    <a:p>
-                      <a:pPr>
-                        <a:defRPr sz="1300">
-                          <a:solidFill>
-                            <a:srgbClr val="F8FAFC"/>
-                          </a:solidFill>
-                          <a:latin typeface="Arial"/>
-                        </a:defRPr>
-                      </a:pPr>
-                      <a:r>
-                        <a:t>Terminal text console only</a:t>
-                      </a:r>
-                    </a:p>
-                  </a:txBody>
-                  <a:tcPr/>
-                </a:tc>
-                <a:tc>
-                  <a:txBody>
-                    <a:bodyPr/>
-                    <a:lstStyle/>
-                    <a:p>
-                      <a:pPr>
-                        <a:defRPr sz="1300">
-                          <a:solidFill>
-                            <a:srgbClr val="F8FAFC"/>
-                          </a:solidFill>
-                          <a:latin typeface="Arial"/>
-                        </a:defRPr>
-                      </a:pPr>
-                      <a:r>
-                        <a:t>Interactive Web Dashboard with Canvas Heatmap</a:t>
-                      </a:r>
-                    </a:p>
-                  </a:txBody>
-                  <a:tcPr/>
-                </a:tc>
-              </a:tr>
-            </a:tbl>
-          </a:graphicData>
-        </a:graphic>
-      </p:graphicFrame>
+        </p:nvSpPr>
+        <p:spPr>
+          <a:xfrm>
+            <a:off x="731520" y="1645920"/>
+            <a:ext cx="10515600" cy="4389120"/>
+          </a:xfrm>
+          <a:prstGeom prst="rect">
+            <a:avLst/>
+          </a:prstGeom>
+          <a:noFill/>
+        </p:spPr>
+        <p:txBody>
+          <a:bodyPr wrap="square">
+            <a:spAutoFit/>
+          </a:bodyPr>
+          <a:lstStyle/>
+          <a:p/>
+          <a:p>
+            <a:pPr>
+              <a:spcBef>
+                <a:spcPts val="1000"/>
+              </a:spcBef>
+              <a:defRPr sz="1500">
+                <a:solidFill>
+                  <a:srgbClr val="F1F5F9"/>
+                </a:solidFill>
+                <a:latin typeface="Arial"/>
+              </a:defRPr>
+            </a:pPr>
+            <a:r>
+              <a:t>• src/agent.c: Agent kinematics, goal-seeking relaxation steering, and social separation force calculations.</a:t>
+            </a:r>
+          </a:p>
+          <a:p>
+            <a:pPr>
+              <a:spcBef>
+                <a:spcPts val="1000"/>
+              </a:spcBef>
+              <a:defRPr sz="1500">
+                <a:solidFill>
+                  <a:srgbClr val="F1F5F9"/>
+                </a:solidFill>
+                <a:latin typeface="Arial"/>
+              </a:defRPr>
+            </a:pPr>
+            <a:r>
+              <a:t>• src/obstacle.c: Circular pillars and rectangular walls with radial repulsion and hard penetration projection.</a:t>
+            </a:r>
+          </a:p>
+          <a:p>
+            <a:pPr>
+              <a:spcBef>
+                <a:spcPts val="1000"/>
+              </a:spcBef>
+              <a:defRPr sz="1500">
+                <a:solidFill>
+                  <a:srgbClr val="F1F5F9"/>
+                </a:solidFill>
+                <a:latin typeface="Arial"/>
+              </a:defRPr>
+            </a:pPr>
+            <a:r>
+              <a:t>• src/spatial_grid.c: Uniform spatial grid using flat Forward-Star linked lists (head and next arrays) for O(N) spatial queries.</a:t>
+            </a:r>
+          </a:p>
+          <a:p>
+            <a:pPr>
+              <a:spcBef>
+                <a:spcPts val="1000"/>
+              </a:spcBef>
+              <a:defRPr sz="1500">
+                <a:solidFill>
+                  <a:srgbClr val="F1F5F9"/>
+                </a:solidFill>
+                <a:latin typeface="Arial"/>
+              </a:defRPr>
+            </a:pPr>
+            <a:r>
+              <a:t>• src/simulation.c: Two-phase double-buffered simulation orchestrator supporting Sequential and OpenMP paths.</a:t>
+            </a:r>
+          </a:p>
+          <a:p>
+            <a:pPr>
+              <a:spcBef>
+                <a:spcPts val="1000"/>
+              </a:spcBef>
+              <a:defRPr sz="1500">
+                <a:solidFill>
+                  <a:srgbClr val="F1F5F9"/>
+                </a:solidFill>
+                <a:latin typeface="Arial"/>
+              </a:defRPr>
+            </a:pPr>
+            <a:r>
+              <a:t>• src/benchmark.c: Multi-trial statistical benchmarking engine computing min, max, mean, median, and stddev.</a:t>
+            </a:r>
+          </a:p>
+          <a:p>
+            <a:pPr>
+              <a:spcBef>
+                <a:spcPts val="1000"/>
+              </a:spcBef>
+              <a:defRPr sz="1500">
+                <a:solidFill>
+                  <a:srgbClr val="F1F5F9"/>
+                </a:solidFill>
+                <a:latin typeface="Arial"/>
+              </a:defRPr>
+            </a:pPr>
+            <a:r>
+              <a:t>• server.py &amp; web/: Zero-dependency Python standard library HTTP server driving an interactive HTML5 Canvas dashboard.</a:t>
+            </a:r>
+          </a:p>
+        </p:txBody>
+      </p:sp>
     </p:spTree>
   </p:cSld>
   <p:clrMapOvr>
@@ -7488,7 +7275,7 @@
     <p:bg>
       <p:bgPr>
         <a:solidFill>
-          <a:srgbClr val="0F172A"/>
+          <a:srgbClr val="0B0F19"/>
         </a:solidFill>
         <a:effectLst/>
       </p:bgPr>
@@ -7561,13 +7348,13 @@
             <a:pPr>
               <a:defRPr sz="2400" b="1">
                 <a:solidFill>
-                  <a:srgbClr val="F8FAFC"/>
+                  <a:srgbClr val="F1F5F9"/>
                 </a:solidFill>
                 <a:latin typeface="Arial"/>
               </a:defRPr>
             </a:pPr>
             <a:r>
-              <a:t>3-Tier System Architecture</a:t>
+              <a:t>Continuous Crowd Dynamics &amp; Force Models</a:t>
             </a:r>
           </a:p>
         </p:txBody>
@@ -7597,49 +7384,65 @@
           <a:p>
             <a:pPr>
               <a:spcBef>
-                <a:spcPts val="1400"/>
+                <a:spcPts val="1200"/>
               </a:spcBef>
-              <a:defRPr sz="1550">
-                <a:solidFill>
-                  <a:srgbClr val="F8FAFC"/>
+              <a:defRPr sz="1500">
+                <a:solidFill>
+                  <a:srgbClr val="F1F5F9"/>
                 </a:solidFill>
                 <a:latin typeface="Arial"/>
               </a:defRPr>
             </a:pPr>
             <a:r>
-              <a:t>• 1. Presentation Layer (Web Dashboard): HTML5, CSS3, and vanilla JavaScript. Features parameter inputs, real-time metrics table, execution log, and HTML5 Canvas spatial density heatmap.</a:t>
+              <a:t>• Goal Steering Acceleration: F_goal = (v_des - v) / tau, pulling agent toward destination at preferred speed (1.3 m/s). Damped smoothly near target.</a:t>
             </a:r>
           </a:p>
           <a:p>
             <a:pPr>
               <a:spcBef>
-                <a:spcPts val="1400"/>
+                <a:spcPts val="1200"/>
               </a:spcBef>
-              <a:defRPr sz="1550">
-                <a:solidFill>
-                  <a:srgbClr val="F8FAFC"/>
+              <a:defRPr sz="1500">
+                <a:solidFill>
+                  <a:srgbClr val="F1F5F9"/>
                 </a:solidFill>
                 <a:latin typeface="Arial"/>
               </a:defRPr>
             </a:pPr>
             <a:r>
-              <a:t>• 2. Integration Layer (Python Server): server.py built with Python standard library (http.server). Binds strictly to 127.0.0.1:8080. Sanitizes parameters, enforces threading.Lock concurrency control, and invokes C binary via subprocess.run(shell=False).</a:t>
+              <a:t>• Inter-Agent Social Separation: F_agents = Sum( A * exp( -(d - 2r) / B ) * n_ij ). Exponential decay over social distance (B = 0.8 m) and linear elastic contact during physical overlap.</a:t>
             </a:r>
           </a:p>
           <a:p>
             <a:pPr>
               <a:spcBef>
-                <a:spcPts val="1400"/>
+                <a:spcPts val="1200"/>
               </a:spcBef>
-              <a:defRPr sz="1550">
-                <a:solidFill>
-                  <a:srgbClr val="F8FAFC"/>
+              <a:defRPr sz="1500">
+                <a:solidFill>
+                  <a:srgbClr val="F1F5F9"/>
                 </a:solidFill>
                 <a:latin typeface="Arial"/>
               </a:defRPr>
             </a:pPr>
             <a:r>
-              <a:t>• 3. Native Computation Engine (crowd_sim): Compiled ISO C11 executable utilizing OpenMP runtime. Implements deterministic math initialization, sequential/parallel simulation loops, periodic wall folding, and emits structured JSON.</a:t>
+              <a:t>• Obstacle Avoidance &amp; Penetration Resolution: Radial repulsive force when within obstacle margin; hard projection projects agent outward if numerical integration causes penetration.</a:t>
+            </a:r>
+          </a:p>
+          <a:p>
+            <a:pPr>
+              <a:spcBef>
+                <a:spcPts val="1200"/>
+              </a:spcBef>
+              <a:defRPr sz="1500">
+                <a:solidFill>
+                  <a:srgbClr val="F1F5F9"/>
+                </a:solidFill>
+                <a:latin typeface="Arial"/>
+              </a:defRPr>
+            </a:pPr>
+            <a:r>
+              <a:t>• Numerical Integration: Clamped acceleration (max 5 m/s²), velocity update (max speed 2.5 m/s), and boundary clamping.</a:t>
             </a:r>
           </a:p>
         </p:txBody>
@@ -7658,7 +7461,7 @@
     <p:bg>
       <p:bgPr>
         <a:solidFill>
-          <a:srgbClr val="0F172A"/>
+          <a:srgbClr val="0B0F19"/>
         </a:solidFill>
         <a:effectLst/>
       </p:bgPr>
@@ -7731,13 +7534,13 @@
             <a:pPr>
               <a:defRPr sz="2400" b="1">
                 <a:solidFill>
-                  <a:srgbClr val="F8FAFC"/>
+                  <a:srgbClr val="F1F5F9"/>
                 </a:solidFill>
                 <a:latin typeface="Arial"/>
               </a:defRPr>
             </a:pPr>
             <a:r>
-              <a:t>Particle Physics &amp; Periodic Wall Folding</a:t>
+              <a:t>Uniform Spatial Grid Partitioning: O(N) vs O(N²)</a:t>
             </a:r>
           </a:p>
         </p:txBody>
@@ -7769,15 +7572,15 @@
               <a:spcBef>
                 <a:spcPts val="1200"/>
               </a:spcBef>
-              <a:defRPr sz="1550">
-                <a:solidFill>
-                  <a:srgbClr val="F8FAFC"/>
+              <a:defRPr sz="1500">
+                <a:solidFill>
+                  <a:srgbClr val="F1F5F9"/>
                 </a:solidFill>
                 <a:latin typeface="Arial"/>
               </a:defRPr>
             </a:pPr>
             <a:r>
-              <a:t>• Particle State Representation: Particle struct containing 4 double-precision fields: { double x, y, vx, vy; } (32 bytes per particle).</a:t>
+              <a:t>• Uniform Discretization: World (100x60 m) divided into uniform grid cells matching interaction radius (C_size = 2.0 m, 50x30 = 1500 cells).</a:t>
             </a:r>
           </a:p>
           <a:p>
@@ -7785,15 +7588,15 @@
               <a:spcBef>
                 <a:spcPts val="1200"/>
               </a:spcBef>
-              <a:defRPr sz="1550">
-                <a:solidFill>
-                  <a:srgbClr val="F8FAFC"/>
+              <a:defRPr sz="1500">
+                <a:solidFill>
+                  <a:srgbClr val="F1F5F9"/>
                 </a:solidFill>
                 <a:latin typeface="Arial"/>
               </a:defRPr>
             </a:pPr>
             <a:r>
-              <a:t>• Kinematic Motion Update: In each discrete step: x_new = x_old + vx, y_new = y_old + vy.</a:t>
+              <a:t>• Forward-Star Representation: Flat head[1500] and next[N] integer arrays avoid dynamic heap allocations during simulation steps.</a:t>
             </a:r>
           </a:p>
           <a:p>
@@ -7801,15 +7604,15 @@
               <a:spcBef>
                 <a:spcPts val="1200"/>
               </a:spcBef>
-              <a:defRPr sz="1550">
-                <a:solidFill>
-                  <a:srgbClr val="F8FAFC"/>
+              <a:defRPr sz="1500">
+                <a:solidFill>
+                  <a:srgbClr val="F1F5F9"/>
                 </a:solidFill>
                 <a:latin typeface="Arial"/>
               </a:defRPr>
             </a:pPr>
             <a:r>
-              <a:t>• The Wall Clamping Flaw: Naive clamping (x = limit) sticks fast-moving particles to walls when displacement exceeds boundary width.</a:t>
+              <a:t>• 9-Cell Neighborhood Search: Because C_size &gt;= r_interact, searching the agent's cell and 8 adjacent cells (3x3 window) is mathematically guaranteed to capture all neighbors.</a:t>
             </a:r>
           </a:p>
           <a:p>
@@ -7817,15 +7620,15 @@
               <a:spcBef>
                 <a:spcPts val="1200"/>
               </a:spcBef>
-              <a:defRPr sz="1550">
-                <a:solidFill>
-                  <a:srgbClr val="F8FAFC"/>
+              <a:defRPr sz="1500">
+                <a:solidFill>
+                  <a:srgbClr val="F1F5F9"/>
                 </a:solidFill>
                 <a:latin typeface="Arial"/>
               </a:defRPr>
             </a:pPr>
             <a:r>
-              <a:t>• Periodic Folding Algorithm (fmod): Coordinates are folded over period = 2.0 * limit using modular arithmetic. If p &gt; limit, p = period - p and velocity is negated (*vel = -*vel). Guarantees exact physics for arbitrary displacement.</a:t>
+              <a:t>• Empirical Work Reduction: Reduces candidate neighbor checks from 49.95M to 1.52M on 1,000 agents (a 96.9% reduction in arithmetic calculations).</a:t>
             </a:r>
           </a:p>
         </p:txBody>
@@ -7844,7 +7647,7 @@
     <p:bg>
       <p:bgPr>
         <a:solidFill>
-          <a:srgbClr val="0F172A"/>
+          <a:srgbClr val="0B0F19"/>
         </a:solidFill>
         <a:effectLst/>
       </p:bgPr>
@@ -7917,13 +7720,13 @@
             <a:pPr>
               <a:defRPr sz="2400" b="1">
                 <a:solidFill>
-                  <a:srgbClr val="F8FAFC"/>
+                  <a:srgbClr val="F1F5F9"/>
                 </a:solidFill>
                 <a:latin typeface="Arial"/>
               </a:defRPr>
             </a:pPr>
             <a:r>
-              <a:t>Sequential Simulation: Single-Threaded Reference</a:t>
+              <a:t>OpenMP Architecture: Data Scoping &amp; Reductions</a:t>
             </a:r>
           </a:p>
         </p:txBody>
@@ -7951,95 +7754,79 @@
           <a:lstStyle/>
           <a:p>
             <a:pPr>
-              <a:defRPr sz="1500">
-                <a:solidFill>
-                  <a:srgbClr val="F8FAFC"/>
-                </a:solidFill>
-                <a:latin typeface="Arial"/>
+              <a:defRPr sz="1300">
+                <a:solidFill>
+                  <a:srgbClr val="38BDF8"/>
+                </a:solidFill>
+                <a:latin typeface="Consolas"/>
               </a:defRPr>
             </a:pPr>
             <a:r>
-              <a:t>The sequential engine serves as the gold-standard reference implementation:</a:t>
+              <a:t>#pragma omp parallel for schedule(static) default(none) \</a:t>
+            </a:r>
+            <a:br/>
+            <a:r>
+              <a:t>    shared(sim) reduction(+:step_checks, step_neighbors)</a:t>
+            </a:r>
+            <a:br/>
+            <a:r>
+              <a:t>for (int i = 0; i &lt; sim-&gt;num_agents; i++) {</a:t>
+            </a:r>
+            <a:br/>
+            <a:r>
+              <a:t>    update_single_agent(sim, i, &amp;step_checks, &amp;step_neighbors);</a:t>
+            </a:r>
+            <a:br/>
+            <a:r>
+              <a:t>}</a:t>
             </a:r>
           </a:p>
           <a:p>
             <a:pPr>
               <a:spcBef>
-                <a:spcPts val="1000"/>
+                <a:spcPts val="800"/>
               </a:spcBef>
-              <a:defRPr sz="1300">
-                <a:solidFill>
-                  <a:srgbClr val="38BDF8"/>
-                </a:solidFill>
-                <a:latin typeface="Consolas"/>
+              <a:defRPr sz="1400">
+                <a:solidFill>
+                  <a:srgbClr val="F1F5F9"/>
+                </a:solidFill>
+                <a:latin typeface="Arial"/>
               </a:defRPr>
             </a:pPr>
             <a:r>
-              <a:t>static void simulate_sequential(Particle *p, int n, int steps)</a:t>
-            </a:r>
-            <a:br/>
-            <a:r>
-              <a:t>{</a:t>
-            </a:r>
-            <a:br/>
-            <a:r>
-              <a:t>    for (int s = 0; s &lt; steps; s++) {</a:t>
-            </a:r>
-            <a:br/>
-            <a:r>
-              <a:t>        for (int i = 0; i &lt; n; i++) {</a:t>
-            </a:r>
-            <a:br/>
-            <a:r>
-              <a:t>            p[i].x += p[i].vx;</a:t>
-            </a:r>
-            <a:br/>
-            <a:r>
-              <a:t>            p[i].y += p[i].vy;</a:t>
-            </a:r>
-            <a:br/>
-            <a:r>
-              <a:t>            reflect(&amp;p[i].x, &amp;p[i].vx, ENV_WIDTH);</a:t>
-            </a:r>
-            <a:br/>
-            <a:r>
-              <a:t>            reflect(&amp;p[i].y, &amp;p[i].vy, ENV_HEIGHT);</a:t>
-            </a:r>
-            <a:br/>
-            <a:r>
-              <a:t>        }</a:t>
-            </a:r>
-            <a:br/>
-            <a:r>
-              <a:t>    }</a:t>
-            </a:r>
-            <a:br/>
-            <a:r>
-              <a:t>}</a:t>
+              <a:t>• Explicit Data Scoping (default(none)): Loop index 'i' is private on stack; 'sim' context is shared; input array is read-only; output is disjointly written.</a:t>
             </a:r>
           </a:p>
           <a:p>
             <a:pPr>
               <a:spcBef>
-                <a:spcPts val="1000"/>
+                <a:spcPts val="800"/>
               </a:spcBef>
               <a:defRPr sz="1400">
                 <a:solidFill>
-                  <a:srgbClr val="94A3B8"/>
+                  <a:srgbClr val="F1F5F9"/>
                 </a:solidFill>
                 <a:latin typeface="Arial"/>
               </a:defRPr>
             </a:pPr>
             <a:r>
-              <a:t>• Outer loop iterates through time steps (temporal dependency).</a:t>
-            </a:r>
-            <a:br/>
-            <a:r>
-              <a:t>• Inner loop updates particles in strict index order (0 to n-1).</a:t>
-            </a:r>
-            <a:br/>
-            <a:r>
-              <a:t>• Timed using omp_get_wtime() immediately around loop bounds.</a:t>
+              <a:t>• Tree Reductions (reduction(+)): Aggregates candidate checks and neighbor counts without expensive #pragma omp atomic locks.</a:t>
+            </a:r>
+          </a:p>
+          <a:p>
+            <a:pPr>
+              <a:spcBef>
+                <a:spcPts val="800"/>
+              </a:spcBef>
+              <a:defRPr sz="1400">
+                <a:solidFill>
+                  <a:srgbClr val="F1F5F9"/>
+                </a:solidFill>
+                <a:latin typeface="Arial"/>
+              </a:defRPr>
+            </a:pPr>
+            <a:r>
+              <a:t>• Zero Lock Contention: Threads execute force calculations completely independently, avoiding mutual exclusion serialization.</a:t>
             </a:r>
           </a:p>
         </p:txBody>
@@ -8058,7 +7845,7 @@
     <p:bg>
       <p:bgPr>
         <a:solidFill>
-          <a:srgbClr val="0F172A"/>
+          <a:srgbClr val="0B0F19"/>
         </a:solidFill>
         <a:effectLst/>
       </p:bgPr>
@@ -8131,27 +7918,484 @@
             <a:pPr>
               <a:defRPr sz="2400" b="1">
                 <a:solidFill>
-                  <a:srgbClr val="F8FAFC"/>
+                  <a:srgbClr val="F1F5F9"/>
                 </a:solidFill>
                 <a:latin typeface="Arial"/>
               </a:defRPr>
             </a:pPr>
             <a:r>
-              <a:t>OpenMP Implementation: Work-Sharing &amp; Scoping</a:t>
-            </a:r>
-          </a:p>
-        </p:txBody>
-      </p:sp>
-      <p:sp>
-        <p:nvSpPr>
-          <p:cNvPr id="4" name="TextBox 3"/>
+              <a:t>Scheduling Policies: Load Balancing in Bottlenecks</a:t>
+            </a:r>
+          </a:p>
+        </p:txBody>
+      </p:sp>
+      <p:graphicFrame>
+        <p:nvGraphicFramePr>
+          <p:cNvPr id="4" name="Table 3"/>
+          <p:cNvGraphicFramePr>
+            <a:graphicFrameLocks noGrp="1"/>
+          </p:cNvGraphicFramePr>
+          <p:nvPr/>
+        </p:nvGraphicFramePr>
+        <p:xfrm>
+          <a:off x="731520" y="1645920"/>
+          <a:ext cx="10698480" cy="2926080"/>
+        </p:xfrm>
+        <a:graphic>
+          <a:graphicData uri="http://schemas.openxmlformats.org/drawingml/2006/table">
+            <a:tbl>
+              <a:tblPr firstRow="1" bandRow="1">
+                <a:tableStyleId>{5C22544A-7EE6-4342-B048-85BDC9FD1C3A}</a:tableStyleId>
+              </a:tblPr>
+              <a:tblGrid>
+                <a:gridCol w="2286000"/>
+                <a:gridCol w="3200400"/>
+                <a:gridCol w="1828800"/>
+                <a:gridCol w="1645920"/>
+                <a:gridCol w="1737360"/>
+              </a:tblGrid>
+              <a:tr h="731520">
+                <a:tc>
+                  <a:txBody>
+                    <a:bodyPr/>
+                    <a:lstStyle/>
+                    <a:p>
+                      <a:pPr>
+                        <a:defRPr sz="1300" b="1">
+                          <a:solidFill>
+                            <a:srgbClr val="38BDF8"/>
+                          </a:solidFill>
+                          <a:latin typeface="Arial"/>
+                        </a:defRPr>
+                      </a:pPr>
+                      <a:r>
+                        <a:t>Policy</a:t>
+                      </a:r>
+                    </a:p>
+                  </a:txBody>
+                  <a:tcPr>
+                    <a:solidFill>
+                      <a:srgbClr val="131A29"/>
+                    </a:solidFill>
+                  </a:tcPr>
+                </a:tc>
+                <a:tc>
+                  <a:txBody>
+                    <a:bodyPr/>
+                    <a:lstStyle/>
+                    <a:p>
+                      <a:pPr>
+                        <a:defRPr sz="1300" b="1">
+                          <a:solidFill>
+                            <a:srgbClr val="38BDF8"/>
+                          </a:solidFill>
+                          <a:latin typeface="Arial"/>
+                        </a:defRPr>
+                      </a:pPr>
+                      <a:r>
+                        <a:t>Directive</a:t>
+                      </a:r>
+                    </a:p>
+                  </a:txBody>
+                  <a:tcPr>
+                    <a:solidFill>
+                      <a:srgbClr val="131A29"/>
+                    </a:solidFill>
+                  </a:tcPr>
+                </a:tc>
+                <a:tc>
+                  <a:txBody>
+                    <a:bodyPr/>
+                    <a:lstStyle/>
+                    <a:p>
+                      <a:pPr>
+                        <a:defRPr sz="1300" b="1">
+                          <a:solidFill>
+                            <a:srgbClr val="38BDF8"/>
+                          </a:solidFill>
+                          <a:latin typeface="Arial"/>
+                        </a:defRPr>
+                      </a:pPr>
+                      <a:r>
+                        <a:t>Runtime (ms)</a:t>
+                      </a:r>
+                    </a:p>
+                  </a:txBody>
+                  <a:tcPr>
+                    <a:solidFill>
+                      <a:srgbClr val="131A29"/>
+                    </a:solidFill>
+                  </a:tcPr>
+                </a:tc>
+                <a:tc>
+                  <a:txBody>
+                    <a:bodyPr/>
+                    <a:lstStyle/>
+                    <a:p>
+                      <a:pPr>
+                        <a:defRPr sz="1300" b="1">
+                          <a:solidFill>
+                            <a:srgbClr val="38BDF8"/>
+                          </a:solidFill>
+                          <a:latin typeface="Arial"/>
+                        </a:defRPr>
+                      </a:pPr>
+                      <a:r>
+                        <a:t>Speedup</a:t>
+                      </a:r>
+                    </a:p>
+                  </a:txBody>
+                  <a:tcPr>
+                    <a:solidFill>
+                      <a:srgbClr val="131A29"/>
+                    </a:solidFill>
+                  </a:tcPr>
+                </a:tc>
+                <a:tc>
+                  <a:txBody>
+                    <a:bodyPr/>
+                    <a:lstStyle/>
+                    <a:p>
+                      <a:pPr>
+                        <a:defRPr sz="1300" b="1">
+                          <a:solidFill>
+                            <a:srgbClr val="38BDF8"/>
+                          </a:solidFill>
+                          <a:latin typeface="Arial"/>
+                        </a:defRPr>
+                      </a:pPr>
+                      <a:r>
+                        <a:t>Efficiency</a:t>
+                      </a:r>
+                    </a:p>
+                  </a:txBody>
+                  <a:tcPr>
+                    <a:solidFill>
+                      <a:srgbClr val="131A29"/>
+                    </a:solidFill>
+                  </a:tcPr>
+                </a:tc>
+              </a:tr>
+              <a:tr h="731520">
+                <a:tc>
+                  <a:txBody>
+                    <a:bodyPr/>
+                    <a:lstStyle/>
+                    <a:p>
+                      <a:pPr>
+                        <a:defRPr sz="1200">
+                          <a:solidFill>
+                            <a:srgbClr val="F1F5F9"/>
+                          </a:solidFill>
+                          <a:latin typeface="Arial"/>
+                        </a:defRPr>
+                      </a:pPr>
+                      <a:r>
+                        <a:t>Static</a:t>
+                      </a:r>
+                    </a:p>
+                  </a:txBody>
+                  <a:tcPr/>
+                </a:tc>
+                <a:tc>
+                  <a:txBody>
+                    <a:bodyPr/>
+                    <a:lstStyle/>
+                    <a:p>
+                      <a:pPr>
+                        <a:defRPr sz="1200">
+                          <a:solidFill>
+                            <a:srgbClr val="F1F5F9"/>
+                          </a:solidFill>
+                          <a:latin typeface="Arial"/>
+                        </a:defRPr>
+                      </a:pPr>
+                      <a:r>
+                        <a:t>schedule(static)</a:t>
+                      </a:r>
+                    </a:p>
+                  </a:txBody>
+                  <a:tcPr/>
+                </a:tc>
+                <a:tc>
+                  <a:txBody>
+                    <a:bodyPr/>
+                    <a:lstStyle/>
+                    <a:p>
+                      <a:pPr>
+                        <a:defRPr sz="1200">
+                          <a:solidFill>
+                            <a:srgbClr val="F1F5F9"/>
+                          </a:solidFill>
+                          <a:latin typeface="Arial"/>
+                        </a:defRPr>
+                      </a:pPr>
+                      <a:r>
+                        <a:t>114.82 ms</a:t>
+                      </a:r>
+                    </a:p>
+                  </a:txBody>
+                  <a:tcPr/>
+                </a:tc>
+                <a:tc>
+                  <a:txBody>
+                    <a:bodyPr/>
+                    <a:lstStyle/>
+                    <a:p>
+                      <a:pPr>
+                        <a:defRPr sz="1200">
+                          <a:solidFill>
+                            <a:srgbClr val="F1F5F9"/>
+                          </a:solidFill>
+                          <a:latin typeface="Arial"/>
+                        </a:defRPr>
+                      </a:pPr>
+                      <a:r>
+                        <a:t>1.59x</a:t>
+                      </a:r>
+                    </a:p>
+                  </a:txBody>
+                  <a:tcPr/>
+                </a:tc>
+                <a:tc>
+                  <a:txBody>
+                    <a:bodyPr/>
+                    <a:lstStyle/>
+                    <a:p>
+                      <a:pPr>
+                        <a:defRPr sz="1200">
+                          <a:solidFill>
+                            <a:srgbClr val="F1F5F9"/>
+                          </a:solidFill>
+                          <a:latin typeface="Arial"/>
+                        </a:defRPr>
+                      </a:pPr>
+                      <a:r>
+                        <a:t>39.7%</a:t>
+                      </a:r>
+                    </a:p>
+                  </a:txBody>
+                  <a:tcPr/>
+                </a:tc>
+              </a:tr>
+              <a:tr h="731520">
+                <a:tc>
+                  <a:txBody>
+                    <a:bodyPr/>
+                    <a:lstStyle/>
+                    <a:p>
+                      <a:pPr>
+                        <a:defRPr sz="1200">
+                          <a:solidFill>
+                            <a:srgbClr val="F1F5F9"/>
+                          </a:solidFill>
+                          <a:latin typeface="Arial"/>
+                        </a:defRPr>
+                      </a:pPr>
+                      <a:r>
+                        <a:t>Dynamic</a:t>
+                      </a:r>
+                    </a:p>
+                  </a:txBody>
+                  <a:tcPr/>
+                </a:tc>
+                <a:tc>
+                  <a:txBody>
+                    <a:bodyPr/>
+                    <a:lstStyle/>
+                    <a:p>
+                      <a:pPr>
+                        <a:defRPr sz="1200">
+                          <a:solidFill>
+                            <a:srgbClr val="F1F5F9"/>
+                          </a:solidFill>
+                          <a:latin typeface="Arial"/>
+                        </a:defRPr>
+                      </a:pPr>
+                      <a:r>
+                        <a:t>schedule(dynamic, 64)</a:t>
+                      </a:r>
+                    </a:p>
+                  </a:txBody>
+                  <a:tcPr/>
+                </a:tc>
+                <a:tc>
+                  <a:txBody>
+                    <a:bodyPr/>
+                    <a:lstStyle/>
+                    <a:p>
+                      <a:pPr>
+                        <a:defRPr sz="1200">
+                          <a:solidFill>
+                            <a:srgbClr val="F1F5F9"/>
+                          </a:solidFill>
+                          <a:latin typeface="Arial"/>
+                        </a:defRPr>
+                      </a:pPr>
+                      <a:r>
+                        <a:t>79.54 ms</a:t>
+                      </a:r>
+                    </a:p>
+                  </a:txBody>
+                  <a:tcPr/>
+                </a:tc>
+                <a:tc>
+                  <a:txBody>
+                    <a:bodyPr/>
+                    <a:lstStyle/>
+                    <a:p>
+                      <a:pPr>
+                        <a:defRPr sz="1200">
+                          <a:solidFill>
+                            <a:srgbClr val="F1F5F9"/>
+                          </a:solidFill>
+                          <a:latin typeface="Arial"/>
+                        </a:defRPr>
+                      </a:pPr>
+                      <a:r>
+                        <a:t>2.29x</a:t>
+                      </a:r>
+                    </a:p>
+                  </a:txBody>
+                  <a:tcPr/>
+                </a:tc>
+                <a:tc>
+                  <a:txBody>
+                    <a:bodyPr/>
+                    <a:lstStyle/>
+                    <a:p>
+                      <a:pPr>
+                        <a:defRPr sz="1200">
+                          <a:solidFill>
+                            <a:srgbClr val="F1F5F9"/>
+                          </a:solidFill>
+                          <a:latin typeface="Arial"/>
+                        </a:defRPr>
+                      </a:pPr>
+                      <a:r>
+                        <a:t>57.3%</a:t>
+                      </a:r>
+                    </a:p>
+                  </a:txBody>
+                  <a:tcPr/>
+                </a:tc>
+              </a:tr>
+              <a:tr h="731520">
+                <a:tc>
+                  <a:txBody>
+                    <a:bodyPr/>
+                    <a:lstStyle/>
+                    <a:p>
+                      <a:pPr>
+                        <a:defRPr sz="1200">
+                          <a:solidFill>
+                            <a:srgbClr val="F1F5F9"/>
+                          </a:solidFill>
+                          <a:latin typeface="Arial"/>
+                        </a:defRPr>
+                      </a:pPr>
+                      <a:r>
+                        <a:t>Guided</a:t>
+                      </a:r>
+                    </a:p>
+                  </a:txBody>
+                  <a:tcPr/>
+                </a:tc>
+                <a:tc>
+                  <a:txBody>
+                    <a:bodyPr/>
+                    <a:lstStyle/>
+                    <a:p>
+                      <a:pPr>
+                        <a:defRPr sz="1200">
+                          <a:solidFill>
+                            <a:srgbClr val="F1F5F9"/>
+                          </a:solidFill>
+                          <a:latin typeface="Arial"/>
+                        </a:defRPr>
+                      </a:pPr>
+                      <a:r>
+                        <a:t>schedule(guided, 64)</a:t>
+                      </a:r>
+                    </a:p>
+                  </a:txBody>
+                  <a:tcPr/>
+                </a:tc>
+                <a:tc>
+                  <a:txBody>
+                    <a:bodyPr/>
+                    <a:lstStyle/>
+                    <a:p>
+                      <a:pPr>
+                        <a:defRPr sz="1200">
+                          <a:solidFill>
+                            <a:srgbClr val="F1F5F9"/>
+                          </a:solidFill>
+                          <a:latin typeface="Arial"/>
+                        </a:defRPr>
+                      </a:pPr>
+                      <a:r>
+                        <a:t>88.06 ms</a:t>
+                      </a:r>
+                    </a:p>
+                  </a:txBody>
+                  <a:tcPr/>
+                </a:tc>
+                <a:tc>
+                  <a:txBody>
+                    <a:bodyPr/>
+                    <a:lstStyle/>
+                    <a:p>
+                      <a:pPr>
+                        <a:defRPr sz="1200">
+                          <a:solidFill>
+                            <a:srgbClr val="F1F5F9"/>
+                          </a:solidFill>
+                          <a:latin typeface="Arial"/>
+                        </a:defRPr>
+                      </a:pPr>
+                      <a:r>
+                        <a:t>2.07x</a:t>
+                      </a:r>
+                    </a:p>
+                  </a:txBody>
+                  <a:tcPr/>
+                </a:tc>
+                <a:tc>
+                  <a:txBody>
+                    <a:bodyPr/>
+                    <a:lstStyle/>
+                    <a:p>
+                      <a:pPr>
+                        <a:defRPr sz="1200">
+                          <a:solidFill>
+                            <a:srgbClr val="F1F5F9"/>
+                          </a:solidFill>
+                          <a:latin typeface="Arial"/>
+                        </a:defRPr>
+                      </a:pPr>
+                      <a:r>
+                        <a:t>51.8%</a:t>
+                      </a:r>
+                    </a:p>
+                  </a:txBody>
+                  <a:tcPr/>
+                </a:tc>
+              </a:tr>
+            </a:tbl>
+          </a:graphicData>
+        </a:graphic>
+      </p:graphicFrame>
+      <p:sp>
+        <p:nvSpPr>
+          <p:cNvPr id="5" name="TextBox 4"/>
           <p:cNvSpPr txBox="1"/>
           <p:nvPr/>
         </p:nvSpPr>
         <p:spPr>
           <a:xfrm>
-            <a:off x="731520" y="1645920"/>
-            <a:ext cx="10515600" cy="4389120"/>
+            <a:off x="731520" y="4754880"/>
+            <a:ext cx="10515600" cy="1645920"/>
           </a:xfrm>
           <a:prstGeom prst="rect">
             <a:avLst/>
@@ -8165,111 +8409,15 @@
           <a:lstStyle/>
           <a:p>
             <a:pPr>
-              <a:defRPr sz="1300">
-                <a:solidFill>
-                  <a:srgbClr val="38BDF8"/>
-                </a:solidFill>
-                <a:latin typeface="Consolas"/>
+              <a:defRPr sz="1400">
+                <a:solidFill>
+                  <a:srgbClr val="4ADE80"/>
+                </a:solidFill>
+                <a:latin typeface="Arial"/>
               </a:defRPr>
             </a:pPr>
             <a:r>
-              <a:t>for (int s = 0; s &lt; steps; s++) {</a:t>
-            </a:r>
-            <a:br/>
-            <a:r>
-              <a:t>    #pragma omp parallel for schedule(static)</a:t>
-            </a:r>
-            <a:br/>
-            <a:r>
-              <a:t>    for (int i = 0; i &lt; n; i++) {</a:t>
-            </a:r>
-            <a:br/>
-            <a:r>
-              <a:t>        p[i].x += p[i].vx;</a:t>
-            </a:r>
-            <a:br/>
-            <a:r>
-              <a:t>        p[i].y += p[i].vy;</a:t>
-            </a:r>
-            <a:br/>
-            <a:r>
-              <a:t>        reflect(&amp;p[i].x, &amp;p[i].vx, ENV_WIDTH);</a:t>
-            </a:r>
-            <a:br/>
-            <a:r>
-              <a:t>        reflect(&amp;p[i].y, &amp;p[i].vy, ENV_HEIGHT);</a:t>
-            </a:r>
-            <a:br/>
-            <a:r>
-              <a:t>    }</a:t>
-            </a:r>
-            <a:br/>
-            <a:r>
-              <a:t>}</a:t>
-            </a:r>
-          </a:p>
-          <a:p>
-            <a:pPr>
-              <a:spcBef>
-                <a:spcPts val="800"/>
-              </a:spcBef>
-              <a:defRPr sz="1450">
-                <a:solidFill>
-                  <a:srgbClr val="F8FAFC"/>
-                </a:solidFill>
-                <a:latin typeface="Arial"/>
-              </a:defRPr>
-            </a:pPr>
-            <a:r>
-              <a:t>• #pragma omp parallel for: Directs compiler to fork worker threads and distribute inner loop iterations.</a:t>
-            </a:r>
-          </a:p>
-          <a:p>
-            <a:pPr>
-              <a:spcBef>
-                <a:spcPts val="800"/>
-              </a:spcBef>
-              <a:defRPr sz="1450">
-                <a:solidFill>
-                  <a:srgbClr val="F8FAFC"/>
-                </a:solidFill>
-                <a:latin typeface="Arial"/>
-              </a:defRPr>
-            </a:pPr>
-            <a:r>
-              <a:t>• schedule(static): Divides N particles into equal chunks of N/T assigned at loop entry. Ideal because each particle requires identical arithmetic work.</a:t>
-            </a:r>
-          </a:p>
-          <a:p>
-            <a:pPr>
-              <a:spcBef>
-                <a:spcPts val="800"/>
-              </a:spcBef>
-              <a:defRPr sz="1450">
-                <a:solidFill>
-                  <a:srgbClr val="F8FAFC"/>
-                </a:solidFill>
-                <a:latin typeface="Arial"/>
-              </a:defRPr>
-            </a:pPr>
-            <a:r>
-              <a:t>• Variable Scoping: Loop index 'i' is implicitly private to each thread; array pointer 'p' is shared.</a:t>
-            </a:r>
-          </a:p>
-          <a:p>
-            <a:pPr>
-              <a:spcBef>
-                <a:spcPts val="800"/>
-              </a:spcBef>
-              <a:defRPr sz="1450">
-                <a:solidFill>
-                  <a:srgbClr val="F8FAFC"/>
-                </a:solidFill>
-                <a:latin typeface="Arial"/>
-              </a:defRPr>
-            </a:pPr>
-            <a:r>
-              <a:t>• Zero Synchronization Overhead: Because threads write to disjoint array index partitions, no mutexes, atomic variables, or critical sections are needed.</a:t>
+              <a:t>Key Insight: Under non-uniform crowd crowding at a doorway, dynamic scheduling dynamically redistributes dense chunks to idle threads, outperforming static scheduling by 35 ms (44% higher efficiency).</a:t>
             </a:r>
           </a:p>
         </p:txBody>

</xml_diff>